<commit_message>
Add the assessment-criteria slide, mascot, and backward design notes
Co-Authored-By: Claude Fable 5 <noreply@anthropic.com>
Claude-Session: https://claude.ai/code/session_01GioPwdWTr1zRaGgkLpRTKj
</commit_message>
<xml_diff>
--- a/output/신문기사-댓글달기-의견쓰기-학생수업-PPT.pptx
+++ b/output/신문기사-댓글달기-의견쓰기-학생수업-PPT.pptx
@@ -21,9 +21,10 @@
     <p:sldId id="269" r:id="rId15"/>
     <p:sldId id="270" r:id="rId16"/>
     <p:sldId id="271" r:id="rId17"/>
+    <p:sldId id="272" r:id="rId18"/>
   </p:sldIdLst>
   <p:notesMasterIdLst>
-    <p:notesMasterId r:id="rId18"/>
+    <p:notesMasterId r:id="rId19"/>
   </p:notesMasterIdLst>
   <p:sldSz cx="12188952" cy="6858000"/>
   <p:notesSz cx="6858000" cy="12188952"/>
@@ -1045,7 +1046,7 @@
           <a:p>
             <a:r>
               <a:rPr lang="en-US" dirty="0"/>
-              <a:t>교사 팁: 제출되면 '학생 의견쓰기' DB에 자동 수집되고 학생 명단의 제출 수가 집계됩니다. 학생 번호는 반드시 목록에서 '선택'해야 집계가 맞습니다. 시범 제출을 한 번 보여 주세요.</a:t>
+              <a:t>교사 팁: 이 기준은 의견쓰기 DB의 교사 이해·연결·표현(각 0~5점, 총 15점) 루브릭과 같습니다. 글을 쓰기 전과 제출 전, 두 번 보여 주면 효과적입니다. 중·고등 확장 수업에서는 7요소 4단계/5단계 확장 루브릭(연수 운영 페이지 토글)을 활용하세요.</a:t>
             </a:r>
             <a:endParaRPr lang="en-US" dirty="0"/>
           </a:p>
@@ -1133,7 +1134,7 @@
           <a:p>
             <a:r>
               <a:rPr lang="en-US" dirty="0"/>
-              <a:t>교사 팁: 세 영역은 평가 루브릭(각 0~5점)과 같습니다. 마무리로 다짐 문장을 다 함께 읽고, 다음 시간에는 친구의 의견에 답글로 생각을 넓히는 활동을 예고할 수 있습니다.</a:t>
+              <a:t>교사 팁: 제출되면 '학생 의견쓰기' DB에 자동 수집되고 학생 명단의 제출 수가 집계됩니다. 학생 번호는 반드시 목록에서 '선택'해야 집계가 맞습니다. 시범 제출을 한 번 보여 주세요.</a:t>
             </a:r>
             <a:endParaRPr lang="en-US" dirty="0"/>
           </a:p>
@@ -1157,6 +1158,94 @@
             <a:fld id="{F7021451-1387-4CA6-816F-3879F97B5CBC}" type="slidenum">
               <a:rPr lang="en-US"/>
               <a:t>16</a:t>
+            </a:fld>
+            <a:endParaRPr lang="en-US"/>
+          </a:p>
+        </p:txBody>
+      </p:sp>
+    </p:spTree>
+    <p:extLst>
+      <p:ext uri="{BB962C8B-B14F-4D97-AF65-F5344CB8AC3E}">
+        <p14:creationId xmlns:p14="http://schemas.microsoft.com/office/powerpoint/2010/main" val="1024086991"/>
+      </p:ext>
+    </p:extLst>
+  </p:cSld>
+  <p:clrMapOvr>
+    <a:masterClrMapping/>
+  </p:clrMapOvr>
+</p:notes>
+</file>
+
+<file path=ppt/notesSlides/notesSlide17.xml><?xml version="1.0" encoding="utf-8"?>
+<p:notes xmlns:a="http://schemas.openxmlformats.org/drawingml/2006/main" xmlns:r="http://schemas.openxmlformats.org/officeDocument/2006/relationships" xmlns:p="http://schemas.openxmlformats.org/presentationml/2006/main">
+  <p:cSld>
+    <p:spTree>
+      <p:nvGrpSpPr>
+        <p:cNvPr id="1" name=""/>
+        <p:cNvGrpSpPr/>
+        <p:nvPr/>
+      </p:nvGrpSpPr>
+      <p:grpSpPr>
+        <a:xfrm>
+          <a:off x="0" y="0"/>
+          <a:ext cx="0" cy="0"/>
+          <a:chOff x="0" y="0"/>
+          <a:chExt cx="0" cy="0"/>
+        </a:xfrm>
+      </p:grpSpPr>
+      <p:sp>
+        <p:nvSpPr>
+          <p:cNvPr id="2" name="Slide Image Placeholder 1"/>
+          <p:cNvSpPr>
+            <a:spLocks noGrp="1" noRot="1" noChangeAspect="1"/>
+          </p:cNvSpPr>
+          <p:nvPr>
+            <p:ph type="sldImg"/>
+          </p:nvPr>
+        </p:nvSpPr>
+        <p:spPr/>
+      </p:sp>
+      <p:sp>
+        <p:nvSpPr>
+          <p:cNvPr id="3" name="Notes Placeholder 2"/>
+          <p:cNvSpPr>
+            <a:spLocks noGrp="1"/>
+          </p:cNvSpPr>
+          <p:nvPr>
+            <p:ph type="body" idx="1"/>
+          </p:nvPr>
+        </p:nvSpPr>
+        <p:spPr/>
+        <p:txBody>
+          <a:bodyPr/>
+          <a:lstStyle/>
+          <a:p>
+            <a:r>
+              <a:rPr lang="en-US" dirty="0"/>
+              <a:t>교사 팁: 세 영역은 평가 루브릭(각 0~5점)과 같습니다. 마무리로 다짐 문장을 다 함께 읽고, 다음 시간에는 친구의 의견에 답글로 생각을 넓히는 활동을 예고할 수 있습니다.</a:t>
+            </a:r>
+            <a:endParaRPr lang="en-US" dirty="0"/>
+          </a:p>
+        </p:txBody>
+      </p:sp>
+      <p:sp>
+        <p:nvSpPr>
+          <p:cNvPr id="4" name="Slide Number Placeholder 3"/>
+          <p:cNvSpPr>
+            <a:spLocks noGrp="1"/>
+          </p:cNvSpPr>
+          <p:nvPr>
+            <p:ph type="sldNum" sz="quarter" idx="10"/>
+          </p:nvPr>
+        </p:nvSpPr>
+        <p:spPr/>
+        <p:txBody>
+          <a:bodyPr/>
+          <a:lstStyle/>
+          <a:p>
+            <a:fld id="{F7021451-1387-4CA6-816F-3879F97B5CBC}" type="slidenum">
+              <a:rPr lang="en-US"/>
+              <a:t>17</a:t>
             </a:fld>
             <a:endParaRPr lang="en-US"/>
           </a:p>
@@ -2254,9 +2343,72 @@
           <a:ln/>
         </p:spPr>
       </p:sp>
-      <p:sp>
-        <p:nvSpPr>
-          <p:cNvPr id="4" name="Text 2"/>
+      <p:pic>
+        <p:nvPicPr>
+          <p:cNvPr id="4" name="Image 0" descr="/root/.claude/skills/synced/edu-thumbnail/assets/bear_wink.png">    </p:cNvPr>
+          <p:cNvPicPr>
+            <a:picLocks noChangeAspect="1"/>
+          </p:cNvPicPr>
+          <p:nvPr/>
+        </p:nvPicPr>
+        <p:blipFill>
+          <a:blip r:embed="rId1"/>
+          <a:stretch>
+            <a:fillRect/>
+          </a:stretch>
+        </p:blipFill>
+        <p:spPr>
+          <a:xfrm>
+            <a:off x="9921240" y="1234440"/>
+            <a:ext cx="1463040" cy="1463040"/>
+          </a:xfrm>
+          <a:prstGeom prst="rect">
+            <a:avLst/>
+          </a:prstGeom>
+        </p:spPr>
+      </p:pic>
+      <p:sp>
+        <p:nvSpPr>
+          <p:cNvPr id="5" name="Text 2"/>
+          <p:cNvSpPr/>
+          <p:nvPr/>
+        </p:nvSpPr>
+        <p:spPr>
+          <a:xfrm>
+            <a:off x="9921240" y="2724912"/>
+            <a:ext cx="1463040" cy="320040"/>
+          </a:xfrm>
+          <a:prstGeom prst="rect">
+            <a:avLst/>
+          </a:prstGeom>
+          <a:noFill/>
+          <a:ln/>
+        </p:spPr>
+        <p:txBody>
+          <a:bodyPr wrap="square" lIns="0" tIns="0" rIns="0" bIns="0" rtlCol="0" anchor="ctr"/>
+          <a:lstStyle/>
+          <a:p>
+            <a:pPr algn="ctr" indent="0" marL="0">
+              <a:buNone/>
+            </a:pPr>
+            <a:r>
+              <a:rPr lang="en-US" sz="1200" b="1" dirty="0">
+                <a:solidFill>
+                  <a:srgbClr val="9BD8D3"/>
+                </a:solidFill>
+                <a:latin typeface="Malgun Gothic" pitchFamily="34" charset="0"/>
+                <a:ea typeface="Malgun Gothic" pitchFamily="34" charset="-122"/>
+                <a:cs typeface="Malgun Gothic" pitchFamily="34" charset="-120"/>
+              </a:rPr>
+              <a:t>곰곰이쌤</a:t>
+            </a:r>
+            <a:endParaRPr lang="en-US" sz="1200" dirty="0"/>
+          </a:p>
+        </p:txBody>
+      </p:sp>
+      <p:sp>
+        <p:nvSpPr>
+          <p:cNvPr id="6" name="Text 3"/>
           <p:cNvSpPr/>
           <p:nvPr/>
         </p:nvSpPr>
@@ -2295,7 +2447,7 @@
       </p:sp>
       <p:sp>
         <p:nvSpPr>
-          <p:cNvPr id="5" name="Text 3"/>
+          <p:cNvPr id="7" name="Text 4"/>
           <p:cNvSpPr/>
           <p:nvPr/>
         </p:nvSpPr>
@@ -2334,7 +2486,7 @@
       </p:sp>
       <p:sp>
         <p:nvSpPr>
-          <p:cNvPr id="6" name="Text 4"/>
+          <p:cNvPr id="8" name="Text 5"/>
           <p:cNvSpPr/>
           <p:nvPr/>
         </p:nvSpPr>
@@ -2373,7 +2525,7 @@
       </p:sp>
       <p:sp>
         <p:nvSpPr>
-          <p:cNvPr id="7" name="Shape 5"/>
+          <p:cNvPr id="9" name="Shape 6"/>
           <p:cNvSpPr/>
           <p:nvPr/>
         </p:nvSpPr>
@@ -2402,7 +2554,7 @@
       </p:sp>
       <p:sp>
         <p:nvSpPr>
-          <p:cNvPr id="8" name="Shape 6"/>
+          <p:cNvPr id="10" name="Shape 7"/>
           <p:cNvSpPr/>
           <p:nvPr/>
         </p:nvSpPr>
@@ -2422,14 +2574,14 @@
       </p:sp>
       <p:pic>
         <p:nvPicPr>
-          <p:cNvPr id="9" name="Image 0" descr="preencoded.png">    </p:cNvPr>
+          <p:cNvPr id="11" name="Image 1" descr="preencoded.png">    </p:cNvPr>
           <p:cNvPicPr>
             <a:picLocks noChangeAspect="1"/>
           </p:cNvPicPr>
           <p:nvPr/>
         </p:nvPicPr>
         <p:blipFill>
-          <a:blip r:embed="rId1"/>
+          <a:blip r:embed="rId2"/>
           <a:stretch>
             <a:fillRect/>
           </a:stretch>
@@ -2446,7 +2598,7 @@
       </p:pic>
       <p:sp>
         <p:nvSpPr>
-          <p:cNvPr id="10" name="Text 7"/>
+          <p:cNvPr id="12" name="Text 8"/>
           <p:cNvSpPr/>
           <p:nvPr/>
         </p:nvSpPr>
@@ -2485,7 +2637,7 @@
       </p:sp>
       <p:sp>
         <p:nvSpPr>
-          <p:cNvPr id="11" name="Text 8"/>
+          <p:cNvPr id="13" name="Text 9"/>
           <p:cNvSpPr/>
           <p:nvPr/>
         </p:nvSpPr>
@@ -2547,7 +2699,7 @@
       </p:sp>
       <p:sp>
         <p:nvSpPr>
-          <p:cNvPr id="12" name="Shape 9"/>
+          <p:cNvPr id="14" name="Shape 10"/>
           <p:cNvSpPr/>
           <p:nvPr/>
         </p:nvSpPr>
@@ -2576,7 +2728,7 @@
       </p:sp>
       <p:sp>
         <p:nvSpPr>
-          <p:cNvPr id="13" name="Shape 10"/>
+          <p:cNvPr id="15" name="Shape 11"/>
           <p:cNvSpPr/>
           <p:nvPr/>
         </p:nvSpPr>
@@ -2596,14 +2748,14 @@
       </p:sp>
       <p:pic>
         <p:nvPicPr>
-          <p:cNvPr id="14" name="Image 1" descr="preencoded.png">    </p:cNvPr>
+          <p:cNvPr id="16" name="Image 2" descr="preencoded.png">    </p:cNvPr>
           <p:cNvPicPr>
             <a:picLocks noChangeAspect="1"/>
           </p:cNvPicPr>
           <p:nvPr/>
         </p:nvPicPr>
         <p:blipFill>
-          <a:blip r:embed="rId2"/>
+          <a:blip r:embed="rId3"/>
           <a:stretch>
             <a:fillRect/>
           </a:stretch>
@@ -2620,7 +2772,7 @@
       </p:pic>
       <p:sp>
         <p:nvSpPr>
-          <p:cNvPr id="15" name="Text 11"/>
+          <p:cNvPr id="17" name="Text 12"/>
           <p:cNvSpPr/>
           <p:nvPr/>
         </p:nvSpPr>
@@ -2659,7 +2811,7 @@
       </p:sp>
       <p:sp>
         <p:nvSpPr>
-          <p:cNvPr id="16" name="Text 12"/>
+          <p:cNvPr id="18" name="Text 13"/>
           <p:cNvSpPr/>
           <p:nvPr/>
         </p:nvSpPr>
@@ -6656,7 +6808,7 @@
               <a:buNone/>
             </a:pPr>
             <a:r>
-              <a:rPr lang="en-US" sz="3200" b="1" dirty="0">
+              <a:rPr lang="en-US" sz="3000" b="1" dirty="0">
                 <a:solidFill>
                   <a:srgbClr val="065A6E"/>
                 </a:solidFill>
@@ -6664,44 +6816,83 @@
                 <a:ea typeface="Malgun Gothic" pitchFamily="34" charset="-122"/>
                 <a:cs typeface="Malgun Gothic" pitchFamily="34" charset="-120"/>
               </a:rPr>
-              <a:t>4단계 · 노션 폼으로 제출해요</a:t>
-            </a:r>
-            <a:endParaRPr lang="en-US" sz="3200" dirty="0"/>
-          </a:p>
-        </p:txBody>
-      </p:sp>
-      <p:sp>
-        <p:nvSpPr>
-          <p:cNvPr id="3" name="Shape 1"/>
-          <p:cNvSpPr/>
-          <p:nvPr/>
-        </p:nvSpPr>
-        <p:spPr>
-          <a:xfrm>
-            <a:off x="822960" y="1554480"/>
-            <a:ext cx="2468880" cy="2834640"/>
+              <a:t>우리 글은 이렇게 평가해요 — 수행평가 기준</a:t>
+            </a:r>
+            <a:endParaRPr lang="en-US" sz="3000" dirty="0"/>
+          </a:p>
+        </p:txBody>
+      </p:sp>
+      <p:sp>
+        <p:nvSpPr>
+          <p:cNvPr id="3" name="Text 1"/>
+          <p:cNvSpPr/>
+          <p:nvPr/>
+        </p:nvSpPr>
+        <p:spPr>
+          <a:xfrm>
+            <a:off x="822960" y="1143000"/>
+            <a:ext cx="10515600" cy="411480"/>
+          </a:xfrm>
+          <a:prstGeom prst="rect">
+            <a:avLst/>
+          </a:prstGeom>
+          <a:noFill/>
+          <a:ln/>
+        </p:spPr>
+        <p:txBody>
+          <a:bodyPr wrap="square" lIns="0" tIns="0" rIns="0" bIns="0" rtlCol="0" anchor="ctr"/>
+          <a:lstStyle/>
+          <a:p>
+            <a:pPr indent="0" marL="0">
+              <a:buNone/>
+            </a:pPr>
+            <a:r>
+              <a:rPr lang="en-US" sz="1600" dirty="0">
+                <a:solidFill>
+                  <a:srgbClr val="5E7078"/>
+                </a:solidFill>
+                <a:latin typeface="Malgun Gothic" pitchFamily="34" charset="0"/>
+                <a:ea typeface="Malgun Gothic" pitchFamily="34" charset="-122"/>
+                <a:cs typeface="Malgun Gothic" pitchFamily="34" charset="-120"/>
+              </a:rPr>
+              <a:t>세 영역을 각각 0~5점으로 봐요. 모두 더하면 15점!</a:t>
+            </a:r>
+            <a:endParaRPr lang="en-US" sz="1600" dirty="0"/>
+          </a:p>
+        </p:txBody>
+      </p:sp>
+      <p:sp>
+        <p:nvSpPr>
+          <p:cNvPr id="4" name="Shape 2"/>
+          <p:cNvSpPr/>
+          <p:nvPr/>
+        </p:nvSpPr>
+        <p:spPr>
+          <a:xfrm>
+            <a:off x="822960" y="1783080"/>
+            <a:ext cx="3291840" cy="3291840"/>
           </a:xfrm>
           <a:prstGeom prst="roundRect">
             <a:avLst>
-              <a:gd name="adj" fmla="val 5185"/>
+              <a:gd name="adj" fmla="val 3889"/>
             </a:avLst>
           </a:prstGeom>
           <a:solidFill>
-            <a:srgbClr val="E3F4F2"/>
+            <a:srgbClr val="E6F3EC"/>
           </a:solidFill>
           <a:ln/>
         </p:spPr>
       </p:sp>
       <p:sp>
         <p:nvSpPr>
-          <p:cNvPr id="4" name="Shape 2"/>
-          <p:cNvSpPr/>
-          <p:nvPr/>
-        </p:nvSpPr>
-        <p:spPr>
-          <a:xfrm>
-            <a:off x="1691640" y="1783080"/>
-            <a:ext cx="731520" cy="731520"/>
+          <p:cNvPr id="5" name="Shape 3"/>
+          <p:cNvSpPr/>
+          <p:nvPr/>
+        </p:nvSpPr>
+        <p:spPr>
+          <a:xfrm>
+            <a:off x="1097280" y="2029968"/>
+            <a:ext cx="566928" cy="566928"/>
           </a:xfrm>
           <a:prstGeom prst="ellipse">
             <a:avLst/>
@@ -6714,7 +6905,7 @@
       </p:sp>
       <p:pic>
         <p:nvPicPr>
-          <p:cNvPr id="5" name="Image 0" descr="preencoded.png">    </p:cNvPr>
+          <p:cNvPr id="6" name="Image 0" descr="preencoded.png">    </p:cNvPr>
           <p:cNvPicPr>
             <a:picLocks noChangeAspect="1"/>
           </p:cNvPicPr>
@@ -6728,8 +6919,8 @@
         </p:blipFill>
         <p:spPr>
           <a:xfrm>
-            <a:off x="1867205" y="1958645"/>
-            <a:ext cx="380390" cy="380390"/>
+            <a:off x="1244681" y="2177369"/>
+            <a:ext cx="272125" cy="272125"/>
           </a:xfrm>
           <a:prstGeom prst="rect">
             <a:avLst/>
@@ -6738,30 +6929,30 @@
       </p:pic>
       <p:sp>
         <p:nvSpPr>
-          <p:cNvPr id="6" name="Text 3"/>
-          <p:cNvSpPr/>
-          <p:nvPr/>
-        </p:nvSpPr>
-        <p:spPr>
-          <a:xfrm>
-            <a:off x="1005840" y="2697480"/>
-            <a:ext cx="2103120" cy="411480"/>
-          </a:xfrm>
-          <a:prstGeom prst="rect">
-            <a:avLst/>
-          </a:prstGeom>
-          <a:noFill/>
-          <a:ln/>
-        </p:spPr>
-        <p:txBody>
-          <a:bodyPr wrap="square" lIns="0" tIns="0" rIns="0" bIns="0" rtlCol="0" anchor="ctr"/>
-          <a:lstStyle/>
-          <a:p>
-            <a:pPr algn="ctr" indent="0" marL="0">
-              <a:buNone/>
-            </a:pPr>
-            <a:r>
-              <a:rPr lang="en-US" sz="1550" b="1" dirty="0">
+          <p:cNvPr id="7" name="Text 4"/>
+          <p:cNvSpPr/>
+          <p:nvPr/>
+        </p:nvSpPr>
+        <p:spPr>
+          <a:xfrm>
+            <a:off x="1783080" y="2103120"/>
+            <a:ext cx="2194560" cy="411480"/>
+          </a:xfrm>
+          <a:prstGeom prst="rect">
+            <a:avLst/>
+          </a:prstGeom>
+          <a:noFill/>
+          <a:ln/>
+        </p:spPr>
+        <p:txBody>
+          <a:bodyPr wrap="square" lIns="0" tIns="0" rIns="0" bIns="0" rtlCol="0" anchor="ctr"/>
+          <a:lstStyle/>
+          <a:p>
+            <a:pPr indent="0" marL="0">
+              <a:buNone/>
+            </a:pPr>
+            <a:r>
+              <a:rPr lang="en-US" sz="1700" b="1" dirty="0">
                 <a:solidFill>
                   <a:srgbClr val="065A6E"/>
                 </a:solidFill>
@@ -6769,41 +6960,80 @@
                 <a:ea typeface="Malgun Gothic" pitchFamily="34" charset="-122"/>
                 <a:cs typeface="Malgun Gothic" pitchFamily="34" charset="-120"/>
               </a:rPr>
-              <a:t>1. 폼 열기</a:t>
-            </a:r>
-            <a:endParaRPr lang="en-US" sz="1550" dirty="0"/>
-          </a:p>
-        </p:txBody>
-      </p:sp>
-      <p:sp>
-        <p:nvSpPr>
-          <p:cNvPr id="7" name="Text 4"/>
-          <p:cNvSpPr/>
-          <p:nvPr/>
-        </p:nvSpPr>
-        <p:spPr>
-          <a:xfrm>
-            <a:off x="1042416" y="3154680"/>
-            <a:ext cx="2029968" cy="1097280"/>
-          </a:xfrm>
-          <a:prstGeom prst="rect">
-            <a:avLst/>
-          </a:prstGeom>
-          <a:noFill/>
-          <a:ln/>
-        </p:spPr>
-        <p:txBody>
-          <a:bodyPr wrap="square" lIns="0" tIns="0" rIns="0" bIns="0" rtlCol="0" anchor="ctr"/>
-          <a:lstStyle/>
-          <a:p>
-            <a:pPr algn="ctr" indent="0" marL="0">
+              <a:t>기사 이해</a:t>
+            </a:r>
+            <a:endParaRPr lang="en-US" sz="1700" dirty="0"/>
+          </a:p>
+        </p:txBody>
+      </p:sp>
+      <p:sp>
+        <p:nvSpPr>
+          <p:cNvPr id="8" name="Text 5"/>
+          <p:cNvSpPr/>
+          <p:nvPr/>
+        </p:nvSpPr>
+        <p:spPr>
+          <a:xfrm>
+            <a:off x="3154680" y="2139696"/>
+            <a:ext cx="777240" cy="347472"/>
+          </a:xfrm>
+          <a:prstGeom prst="rect">
+            <a:avLst/>
+          </a:prstGeom>
+          <a:noFill/>
+          <a:ln/>
+        </p:spPr>
+        <p:txBody>
+          <a:bodyPr wrap="square" lIns="0" tIns="0" rIns="0" bIns="0" rtlCol="0" anchor="ctr"/>
+          <a:lstStyle/>
+          <a:p>
+            <a:pPr algn="r" indent="0" marL="0">
+              <a:buNone/>
+            </a:pPr>
+            <a:r>
+              <a:rPr lang="en-US" sz="1200" b="1" dirty="0">
+                <a:solidFill>
+                  <a:srgbClr val="2C8A5B"/>
+                </a:solidFill>
+                <a:latin typeface="Malgun Gothic" pitchFamily="34" charset="0"/>
+                <a:ea typeface="Malgun Gothic" pitchFamily="34" charset="-122"/>
+                <a:cs typeface="Malgun Gothic" pitchFamily="34" charset="-120"/>
+              </a:rPr>
+              <a:t>0~5점</a:t>
+            </a:r>
+            <a:endParaRPr lang="en-US" sz="1200" dirty="0"/>
+          </a:p>
+        </p:txBody>
+      </p:sp>
+      <p:sp>
+        <p:nvSpPr>
+          <p:cNvPr id="9" name="Text 6"/>
+          <p:cNvSpPr/>
+          <p:nvPr/>
+        </p:nvSpPr>
+        <p:spPr>
+          <a:xfrm>
+            <a:off x="1115568" y="2788920"/>
+            <a:ext cx="2706624" cy="868680"/>
+          </a:xfrm>
+          <a:prstGeom prst="rect">
+            <a:avLst/>
+          </a:prstGeom>
+          <a:noFill/>
+          <a:ln/>
+        </p:spPr>
+        <p:txBody>
+          <a:bodyPr wrap="square" lIns="0" tIns="0" rIns="0" bIns="0" rtlCol="0" anchor="ctr"/>
+          <a:lstStyle/>
+          <a:p>
+            <a:pPr indent="0" marL="0">
               <a:lnSpc>
                 <a:spcPct val="115000"/>
               </a:lnSpc>
               <a:buNone/>
             </a:pPr>
             <a:r>
-              <a:rPr lang="en-US" sz="1200" dirty="0">
+              <a:rPr lang="en-US" sz="1300" dirty="0">
                 <a:solidFill>
                   <a:srgbClr val="26343B"/>
                 </a:solidFill>
@@ -6811,86 +7041,27 @@
                 <a:ea typeface="Malgun Gothic" pitchFamily="34" charset="-122"/>
                 <a:cs typeface="Malgun Gothic" pitchFamily="34" charset="-120"/>
               </a:rPr>
-              <a:t>기사 페이지에 있는 ‘의견쓰기’ 폼을 열어요.</a:t>
-            </a:r>
-            <a:endParaRPr lang="en-US" sz="1200" dirty="0"/>
-          </a:p>
-        </p:txBody>
-      </p:sp>
-      <p:sp>
-        <p:nvSpPr>
-          <p:cNvPr id="8" name="Text 5"/>
-          <p:cNvSpPr/>
-          <p:nvPr/>
-        </p:nvSpPr>
-        <p:spPr>
-          <a:xfrm>
-            <a:off x="3218688" y="2743200"/>
-            <a:ext cx="365760" cy="457200"/>
-          </a:xfrm>
-          <a:prstGeom prst="rect">
-            <a:avLst/>
-          </a:prstGeom>
-          <a:noFill/>
-          <a:ln/>
-        </p:spPr>
-        <p:txBody>
-          <a:bodyPr wrap="square" lIns="0" tIns="0" rIns="0" bIns="0" rtlCol="0" anchor="ctr"/>
-          <a:lstStyle/>
-          <a:p>
-            <a:pPr algn="ctr" indent="0" marL="0">
-              <a:buNone/>
-            </a:pPr>
-            <a:r>
-              <a:rPr lang="en-US" sz="2000" b="1" dirty="0">
-                <a:solidFill>
-                  <a:srgbClr val="5E7078"/>
-                </a:solidFill>
-                <a:latin typeface="Malgun Gothic" pitchFamily="34" charset="0"/>
-                <a:ea typeface="Malgun Gothic" pitchFamily="34" charset="-122"/>
-                <a:cs typeface="Malgun Gothic" pitchFamily="34" charset="-120"/>
-              </a:rPr>
-              <a:t>→</a:t>
-            </a:r>
-            <a:endParaRPr lang="en-US" sz="2000" dirty="0"/>
-          </a:p>
-        </p:txBody>
-      </p:sp>
-      <p:sp>
-        <p:nvSpPr>
-          <p:cNvPr id="9" name="Shape 6"/>
-          <p:cNvSpPr/>
-          <p:nvPr/>
-        </p:nvSpPr>
-        <p:spPr>
-          <a:xfrm>
-            <a:off x="3520440" y="1554480"/>
-            <a:ext cx="2468880" cy="2834640"/>
+              <a:t>기사의 핵심 내용을 바르게 이해하고 내 말로 썼나요?</a:t>
+            </a:r>
+            <a:endParaRPr lang="en-US" sz="1300" dirty="0"/>
+          </a:p>
+        </p:txBody>
+      </p:sp>
+      <p:sp>
+        <p:nvSpPr>
+          <p:cNvPr id="10" name="Shape 7"/>
+          <p:cNvSpPr/>
+          <p:nvPr/>
+        </p:nvSpPr>
+        <p:spPr>
+          <a:xfrm>
+            <a:off x="1078992" y="3703320"/>
+            <a:ext cx="2779776" cy="1170432"/>
           </a:xfrm>
           <a:prstGeom prst="roundRect">
             <a:avLst>
-              <a:gd name="adj" fmla="val 5185"/>
+              <a:gd name="adj" fmla="val 7813"/>
             </a:avLst>
-          </a:prstGeom>
-          <a:solidFill>
-            <a:srgbClr val="E3F4F2"/>
-          </a:solidFill>
-          <a:ln/>
-        </p:spPr>
-      </p:sp>
-      <p:sp>
-        <p:nvSpPr>
-          <p:cNvPr id="10" name="Shape 7"/>
-          <p:cNvSpPr/>
-          <p:nvPr/>
-        </p:nvSpPr>
-        <p:spPr>
-          <a:xfrm>
-            <a:off x="4389120" y="1783080"/>
-            <a:ext cx="731520" cy="731520"/>
-          </a:xfrm>
-          <a:prstGeom prst="ellipse">
-            <a:avLst/>
           </a:prstGeom>
           <a:solidFill>
             <a:srgbClr val="FFFFFF"/>
@@ -6898,9 +7069,110 @@
           <a:ln/>
         </p:spPr>
       </p:sp>
+      <p:sp>
+        <p:nvSpPr>
+          <p:cNvPr id="11" name="Text 8"/>
+          <p:cNvSpPr/>
+          <p:nvPr/>
+        </p:nvSpPr>
+        <p:spPr>
+          <a:xfrm>
+            <a:off x="1225296" y="3803904"/>
+            <a:ext cx="2487168" cy="1005840"/>
+          </a:xfrm>
+          <a:prstGeom prst="rect">
+            <a:avLst/>
+          </a:prstGeom>
+          <a:noFill/>
+          <a:ln/>
+        </p:spPr>
+        <p:txBody>
+          <a:bodyPr wrap="square" lIns="0" tIns="0" rIns="0" bIns="0" rtlCol="0" anchor="ctr"/>
+          <a:lstStyle/>
+          <a:p>
+            <a:pPr indent="0" marL="0">
+              <a:lnSpc>
+                <a:spcPct val="115000"/>
+              </a:lnSpc>
+              <a:buNone/>
+            </a:pPr>
+            <a:r>
+              <a:rPr lang="en-US" sz="1150" b="1" dirty="0">
+                <a:solidFill>
+                  <a:srgbClr val="B8860B"/>
+                </a:solidFill>
+                <a:latin typeface="Malgun Gothic" pitchFamily="34" charset="0"/>
+                <a:ea typeface="Malgun Gothic" pitchFamily="34" charset="-122"/>
+                <a:cs typeface="Malgun Gothic" pitchFamily="34" charset="-120"/>
+              </a:rPr>
+              <a:t>⭐ 5점의 모습  </a:t>
+            </a:r>
+            <a:pPr indent="0" marL="0">
+              <a:lnSpc>
+                <a:spcPct val="115000"/>
+              </a:lnSpc>
+              <a:buNone/>
+            </a:pPr>
+            <a:r>
+              <a:rPr lang="en-US" sz="1150" dirty="0">
+                <a:solidFill>
+                  <a:srgbClr val="26343B"/>
+                </a:solidFill>
+                <a:latin typeface="Malgun Gothic" pitchFamily="34" charset="0"/>
+                <a:ea typeface="Malgun Gothic" pitchFamily="34" charset="-122"/>
+                <a:cs typeface="Malgun Gothic" pitchFamily="34" charset="-120"/>
+              </a:rPr>
+              <a:t>기사 속 중요한 사실을 내 말로 설명하고, 서로 다른 입장까지 짚으면 최고!</a:t>
+            </a:r>
+            <a:endParaRPr lang="en-US" sz="1150" dirty="0"/>
+          </a:p>
+        </p:txBody>
+      </p:sp>
+      <p:sp>
+        <p:nvSpPr>
+          <p:cNvPr id="12" name="Shape 9"/>
+          <p:cNvSpPr/>
+          <p:nvPr/>
+        </p:nvSpPr>
+        <p:spPr>
+          <a:xfrm>
+            <a:off x="4434840" y="1783080"/>
+            <a:ext cx="3291840" cy="3291840"/>
+          </a:xfrm>
+          <a:prstGeom prst="roundRect">
+            <a:avLst>
+              <a:gd name="adj" fmla="val 3889"/>
+            </a:avLst>
+          </a:prstGeom>
+          <a:solidFill>
+            <a:srgbClr val="E6F3EC"/>
+          </a:solidFill>
+          <a:ln/>
+        </p:spPr>
+      </p:sp>
+      <p:sp>
+        <p:nvSpPr>
+          <p:cNvPr id="13" name="Shape 10"/>
+          <p:cNvSpPr/>
+          <p:nvPr/>
+        </p:nvSpPr>
+        <p:spPr>
+          <a:xfrm>
+            <a:off x="4709160" y="2029968"/>
+            <a:ext cx="566928" cy="566928"/>
+          </a:xfrm>
+          <a:prstGeom prst="ellipse">
+            <a:avLst/>
+          </a:prstGeom>
+          <a:solidFill>
+            <a:srgbClr val="FFFFFF"/>
+          </a:solidFill>
+          <a:ln/>
+        </p:spPr>
+      </p:sp>
       <p:pic>
         <p:nvPicPr>
-          <p:cNvPr id="11" name="Image 1" descr="preencoded.png">    </p:cNvPr>
+          <p:cNvPr id="14" name="Image 1" descr="preencoded.png">    </p:cNvPr>
           <p:cNvPicPr>
             <a:picLocks noChangeAspect="1"/>
           </p:cNvPicPr>
@@ -6914,8 +7186,8 @@
         </p:blipFill>
         <p:spPr>
           <a:xfrm>
-            <a:off x="4564685" y="1958645"/>
-            <a:ext cx="380390" cy="380390"/>
+            <a:off x="4856561" y="2177369"/>
+            <a:ext cx="272125" cy="272125"/>
           </a:xfrm>
           <a:prstGeom prst="rect">
             <a:avLst/>
@@ -6924,30 +7196,30 @@
       </p:pic>
       <p:sp>
         <p:nvSpPr>
-          <p:cNvPr id="12" name="Text 8"/>
-          <p:cNvSpPr/>
-          <p:nvPr/>
-        </p:nvSpPr>
-        <p:spPr>
-          <a:xfrm>
-            <a:off x="3703320" y="2697480"/>
-            <a:ext cx="2103120" cy="411480"/>
-          </a:xfrm>
-          <a:prstGeom prst="rect">
-            <a:avLst/>
-          </a:prstGeom>
-          <a:noFill/>
-          <a:ln/>
-        </p:spPr>
-        <p:txBody>
-          <a:bodyPr wrap="square" lIns="0" tIns="0" rIns="0" bIns="0" rtlCol="0" anchor="ctr"/>
-          <a:lstStyle/>
-          <a:p>
-            <a:pPr algn="ctr" indent="0" marL="0">
-              <a:buNone/>
-            </a:pPr>
-            <a:r>
-              <a:rPr lang="en-US" sz="1550" b="1" dirty="0">
+          <p:cNvPr id="15" name="Text 11"/>
+          <p:cNvSpPr/>
+          <p:nvPr/>
+        </p:nvSpPr>
+        <p:spPr>
+          <a:xfrm>
+            <a:off x="5394960" y="2103120"/>
+            <a:ext cx="2194560" cy="411480"/>
+          </a:xfrm>
+          <a:prstGeom prst="rect">
+            <a:avLst/>
+          </a:prstGeom>
+          <a:noFill/>
+          <a:ln/>
+        </p:spPr>
+        <p:txBody>
+          <a:bodyPr wrap="square" lIns="0" tIns="0" rIns="0" bIns="0" rtlCol="0" anchor="ctr"/>
+          <a:lstStyle/>
+          <a:p>
+            <a:pPr indent="0" marL="0">
+              <a:buNone/>
+            </a:pPr>
+            <a:r>
+              <a:rPr lang="en-US" sz="1700" b="1" dirty="0">
                 <a:solidFill>
                   <a:srgbClr val="065A6E"/>
                 </a:solidFill>
@@ -6955,41 +7227,80 @@
                 <a:ea typeface="Malgun Gothic" pitchFamily="34" charset="-122"/>
                 <a:cs typeface="Malgun Gothic" pitchFamily="34" charset="-120"/>
               </a:rPr>
-              <a:t>2. 내 번호 선택</a:t>
-            </a:r>
-            <a:endParaRPr lang="en-US" sz="1550" dirty="0"/>
-          </a:p>
-        </p:txBody>
-      </p:sp>
-      <p:sp>
-        <p:nvSpPr>
-          <p:cNvPr id="13" name="Text 9"/>
-          <p:cNvSpPr/>
-          <p:nvPr/>
-        </p:nvSpPr>
-        <p:spPr>
-          <a:xfrm>
-            <a:off x="3739896" y="3154680"/>
-            <a:ext cx="2029968" cy="1097280"/>
-          </a:xfrm>
-          <a:prstGeom prst="rect">
-            <a:avLst/>
-          </a:prstGeom>
-          <a:noFill/>
-          <a:ln/>
-        </p:spPr>
-        <p:txBody>
-          <a:bodyPr wrap="square" lIns="0" tIns="0" rIns="0" bIns="0" rtlCol="0" anchor="ctr"/>
-          <a:lstStyle/>
-          <a:p>
-            <a:pPr algn="ctr" indent="0" marL="0">
+              <a:t>생각 연결</a:t>
+            </a:r>
+            <a:endParaRPr lang="en-US" sz="1700" dirty="0"/>
+          </a:p>
+        </p:txBody>
+      </p:sp>
+      <p:sp>
+        <p:nvSpPr>
+          <p:cNvPr id="16" name="Text 12"/>
+          <p:cNvSpPr/>
+          <p:nvPr/>
+        </p:nvSpPr>
+        <p:spPr>
+          <a:xfrm>
+            <a:off x="6766560" y="2139696"/>
+            <a:ext cx="777240" cy="347472"/>
+          </a:xfrm>
+          <a:prstGeom prst="rect">
+            <a:avLst/>
+          </a:prstGeom>
+          <a:noFill/>
+          <a:ln/>
+        </p:spPr>
+        <p:txBody>
+          <a:bodyPr wrap="square" lIns="0" tIns="0" rIns="0" bIns="0" rtlCol="0" anchor="ctr"/>
+          <a:lstStyle/>
+          <a:p>
+            <a:pPr algn="r" indent="0" marL="0">
+              <a:buNone/>
+            </a:pPr>
+            <a:r>
+              <a:rPr lang="en-US" sz="1200" b="1" dirty="0">
+                <a:solidFill>
+                  <a:srgbClr val="2C8A5B"/>
+                </a:solidFill>
+                <a:latin typeface="Malgun Gothic" pitchFamily="34" charset="0"/>
+                <a:ea typeface="Malgun Gothic" pitchFamily="34" charset="-122"/>
+                <a:cs typeface="Malgun Gothic" pitchFamily="34" charset="-120"/>
+              </a:rPr>
+              <a:t>0~5점</a:t>
+            </a:r>
+            <a:endParaRPr lang="en-US" sz="1200" dirty="0"/>
+          </a:p>
+        </p:txBody>
+      </p:sp>
+      <p:sp>
+        <p:nvSpPr>
+          <p:cNvPr id="17" name="Text 13"/>
+          <p:cNvSpPr/>
+          <p:nvPr/>
+        </p:nvSpPr>
+        <p:spPr>
+          <a:xfrm>
+            <a:off x="4727448" y="2788920"/>
+            <a:ext cx="2706624" cy="868680"/>
+          </a:xfrm>
+          <a:prstGeom prst="rect">
+            <a:avLst/>
+          </a:prstGeom>
+          <a:noFill/>
+          <a:ln/>
+        </p:spPr>
+        <p:txBody>
+          <a:bodyPr wrap="square" lIns="0" tIns="0" rIns="0" bIns="0" rtlCol="0" anchor="ctr"/>
+          <a:lstStyle/>
+          <a:p>
+            <a:pPr indent="0" marL="0">
               <a:lnSpc>
                 <a:spcPct val="115000"/>
               </a:lnSpc>
               <a:buNone/>
             </a:pPr>
             <a:r>
-              <a:rPr lang="en-US" sz="1200" dirty="0">
+              <a:rPr lang="en-US" sz="1300" dirty="0">
                 <a:solidFill>
                   <a:srgbClr val="26343B"/>
                 </a:solidFill>
@@ -6997,86 +7308,27 @@
                 <a:ea typeface="Malgun Gothic" pitchFamily="34" charset="-122"/>
                 <a:cs typeface="Malgun Gothic" pitchFamily="34" charset="-120"/>
               </a:rPr>
-              <a:t>목록에서 내 학생 번호를 ‘선택’해요. 직접 쓰지 않아요!</a:t>
-            </a:r>
-            <a:endParaRPr lang="en-US" sz="1200" dirty="0"/>
-          </a:p>
-        </p:txBody>
-      </p:sp>
-      <p:sp>
-        <p:nvSpPr>
-          <p:cNvPr id="14" name="Text 10"/>
-          <p:cNvSpPr/>
-          <p:nvPr/>
-        </p:nvSpPr>
-        <p:spPr>
-          <a:xfrm>
-            <a:off x="5916168" y="2743200"/>
-            <a:ext cx="365760" cy="457200"/>
-          </a:xfrm>
-          <a:prstGeom prst="rect">
-            <a:avLst/>
-          </a:prstGeom>
-          <a:noFill/>
-          <a:ln/>
-        </p:spPr>
-        <p:txBody>
-          <a:bodyPr wrap="square" lIns="0" tIns="0" rIns="0" bIns="0" rtlCol="0" anchor="ctr"/>
-          <a:lstStyle/>
-          <a:p>
-            <a:pPr algn="ctr" indent="0" marL="0">
-              <a:buNone/>
-            </a:pPr>
-            <a:r>
-              <a:rPr lang="en-US" sz="2000" b="1" dirty="0">
-                <a:solidFill>
-                  <a:srgbClr val="5E7078"/>
-                </a:solidFill>
-                <a:latin typeface="Malgun Gothic" pitchFamily="34" charset="0"/>
-                <a:ea typeface="Malgun Gothic" pitchFamily="34" charset="-122"/>
-                <a:cs typeface="Malgun Gothic" pitchFamily="34" charset="-120"/>
-              </a:rPr>
-              <a:t>→</a:t>
-            </a:r>
-            <a:endParaRPr lang="en-US" sz="2000" dirty="0"/>
-          </a:p>
-        </p:txBody>
-      </p:sp>
-      <p:sp>
-        <p:nvSpPr>
-          <p:cNvPr id="15" name="Shape 11"/>
-          <p:cNvSpPr/>
-          <p:nvPr/>
-        </p:nvSpPr>
-        <p:spPr>
-          <a:xfrm>
-            <a:off x="6217920" y="1554480"/>
-            <a:ext cx="2468880" cy="2834640"/>
+              <a:t>의견과 까닭을 기사 내용과 연결했나요?</a:t>
+            </a:r>
+            <a:endParaRPr lang="en-US" sz="1300" dirty="0"/>
+          </a:p>
+        </p:txBody>
+      </p:sp>
+      <p:sp>
+        <p:nvSpPr>
+          <p:cNvPr id="18" name="Shape 14"/>
+          <p:cNvSpPr/>
+          <p:nvPr/>
+        </p:nvSpPr>
+        <p:spPr>
+          <a:xfrm>
+            <a:off x="4690872" y="3703320"/>
+            <a:ext cx="2779776" cy="1170432"/>
           </a:xfrm>
           <a:prstGeom prst="roundRect">
             <a:avLst>
-              <a:gd name="adj" fmla="val 5185"/>
+              <a:gd name="adj" fmla="val 7813"/>
             </a:avLst>
-          </a:prstGeom>
-          <a:solidFill>
-            <a:srgbClr val="E3F4F2"/>
-          </a:solidFill>
-          <a:ln/>
-        </p:spPr>
-      </p:sp>
-      <p:sp>
-        <p:nvSpPr>
-          <p:cNvPr id="16" name="Shape 12"/>
-          <p:cNvSpPr/>
-          <p:nvPr/>
-        </p:nvSpPr>
-        <p:spPr>
-          <a:xfrm>
-            <a:off x="7086600" y="1783080"/>
-            <a:ext cx="731520" cy="731520"/>
-          </a:xfrm>
-          <a:prstGeom prst="ellipse">
-            <a:avLst/>
           </a:prstGeom>
           <a:solidFill>
             <a:srgbClr val="FFFFFF"/>
@@ -7084,9 +7336,110 @@
           <a:ln/>
         </p:spPr>
       </p:sp>
+      <p:sp>
+        <p:nvSpPr>
+          <p:cNvPr id="19" name="Text 15"/>
+          <p:cNvSpPr/>
+          <p:nvPr/>
+        </p:nvSpPr>
+        <p:spPr>
+          <a:xfrm>
+            <a:off x="4837176" y="3803904"/>
+            <a:ext cx="2487168" cy="1005840"/>
+          </a:xfrm>
+          <a:prstGeom prst="rect">
+            <a:avLst/>
+          </a:prstGeom>
+          <a:noFill/>
+          <a:ln/>
+        </p:spPr>
+        <p:txBody>
+          <a:bodyPr wrap="square" lIns="0" tIns="0" rIns="0" bIns="0" rtlCol="0" anchor="ctr"/>
+          <a:lstStyle/>
+          <a:p>
+            <a:pPr indent="0" marL="0">
+              <a:lnSpc>
+                <a:spcPct val="115000"/>
+              </a:lnSpc>
+              <a:buNone/>
+            </a:pPr>
+            <a:r>
+              <a:rPr lang="en-US" sz="1150" b="1" dirty="0">
+                <a:solidFill>
+                  <a:srgbClr val="B8860B"/>
+                </a:solidFill>
+                <a:latin typeface="Malgun Gothic" pitchFamily="34" charset="0"/>
+                <a:ea typeface="Malgun Gothic" pitchFamily="34" charset="-122"/>
+                <a:cs typeface="Malgun Gothic" pitchFamily="34" charset="-120"/>
+              </a:rPr>
+              <a:t>⭐ 5점의 모습  </a:t>
+            </a:r>
+            <a:pPr indent="0" marL="0">
+              <a:lnSpc>
+                <a:spcPct val="115000"/>
+              </a:lnSpc>
+              <a:buNone/>
+            </a:pPr>
+            <a:r>
+              <a:rPr lang="en-US" sz="1150" dirty="0">
+                <a:solidFill>
+                  <a:srgbClr val="26343B"/>
+                </a:solidFill>
+                <a:latin typeface="Malgun Gothic" pitchFamily="34" charset="0"/>
+                <a:ea typeface="Malgun Gothic" pitchFamily="34" charset="-122"/>
+                <a:cs typeface="Malgun Gothic" pitchFamily="34" charset="-120"/>
+              </a:rPr>
+              <a:t>내 경험·근거·예시로 까닭을 뒷받침하고, 다른 가능성까지 생각하면 최고!</a:t>
+            </a:r>
+            <a:endParaRPr lang="en-US" sz="1150" dirty="0"/>
+          </a:p>
+        </p:txBody>
+      </p:sp>
+      <p:sp>
+        <p:nvSpPr>
+          <p:cNvPr id="20" name="Shape 16"/>
+          <p:cNvSpPr/>
+          <p:nvPr/>
+        </p:nvSpPr>
+        <p:spPr>
+          <a:xfrm>
+            <a:off x="8046720" y="1783080"/>
+            <a:ext cx="3291840" cy="3291840"/>
+          </a:xfrm>
+          <a:prstGeom prst="roundRect">
+            <a:avLst>
+              <a:gd name="adj" fmla="val 3889"/>
+            </a:avLst>
+          </a:prstGeom>
+          <a:solidFill>
+            <a:srgbClr val="E6F3EC"/>
+          </a:solidFill>
+          <a:ln/>
+        </p:spPr>
+      </p:sp>
+      <p:sp>
+        <p:nvSpPr>
+          <p:cNvPr id="21" name="Shape 17"/>
+          <p:cNvSpPr/>
+          <p:nvPr/>
+        </p:nvSpPr>
+        <p:spPr>
+          <a:xfrm>
+            <a:off x="8321040" y="2029968"/>
+            <a:ext cx="566928" cy="566928"/>
+          </a:xfrm>
+          <a:prstGeom prst="ellipse">
+            <a:avLst/>
+          </a:prstGeom>
+          <a:solidFill>
+            <a:srgbClr val="FFFFFF"/>
+          </a:solidFill>
+          <a:ln/>
+        </p:spPr>
+      </p:sp>
       <p:pic>
         <p:nvPicPr>
-          <p:cNvPr id="17" name="Image 2" descr="preencoded.png">    </p:cNvPr>
+          <p:cNvPr id="22" name="Image 2" descr="preencoded.png">    </p:cNvPr>
           <p:cNvPicPr>
             <a:picLocks noChangeAspect="1"/>
           </p:cNvPicPr>
@@ -7100,8 +7453,8 @@
         </p:blipFill>
         <p:spPr>
           <a:xfrm>
-            <a:off x="7262165" y="1958645"/>
-            <a:ext cx="380390" cy="380390"/>
+            <a:off x="8468441" y="2177369"/>
+            <a:ext cx="272125" cy="272125"/>
           </a:xfrm>
           <a:prstGeom prst="rect">
             <a:avLst/>
@@ -7110,30 +7463,30 @@
       </p:pic>
       <p:sp>
         <p:nvSpPr>
-          <p:cNvPr id="18" name="Text 13"/>
-          <p:cNvSpPr/>
-          <p:nvPr/>
-        </p:nvSpPr>
-        <p:spPr>
-          <a:xfrm>
-            <a:off x="6400800" y="2697480"/>
-            <a:ext cx="2103120" cy="411480"/>
-          </a:xfrm>
-          <a:prstGeom prst="rect">
-            <a:avLst/>
-          </a:prstGeom>
-          <a:noFill/>
-          <a:ln/>
-        </p:spPr>
-        <p:txBody>
-          <a:bodyPr wrap="square" lIns="0" tIns="0" rIns="0" bIns="0" rtlCol="0" anchor="ctr"/>
-          <a:lstStyle/>
-          <a:p>
-            <a:pPr algn="ctr" indent="0" marL="0">
-              <a:buNone/>
-            </a:pPr>
-            <a:r>
-              <a:rPr lang="en-US" sz="1550" b="1" dirty="0">
+          <p:cNvPr id="23" name="Text 18"/>
+          <p:cNvSpPr/>
+          <p:nvPr/>
+        </p:nvSpPr>
+        <p:spPr>
+          <a:xfrm>
+            <a:off x="9006840" y="2103120"/>
+            <a:ext cx="2194560" cy="411480"/>
+          </a:xfrm>
+          <a:prstGeom prst="rect">
+            <a:avLst/>
+          </a:prstGeom>
+          <a:noFill/>
+          <a:ln/>
+        </p:spPr>
+        <p:txBody>
+          <a:bodyPr wrap="square" lIns="0" tIns="0" rIns="0" bIns="0" rtlCol="0" anchor="ctr"/>
+          <a:lstStyle/>
+          <a:p>
+            <a:pPr indent="0" marL="0">
+              <a:buNone/>
+            </a:pPr>
+            <a:r>
+              <a:rPr lang="en-US" sz="1700" b="1" dirty="0">
                 <a:solidFill>
                   <a:srgbClr val="065A6E"/>
                 </a:solidFill>
@@ -7141,41 +7494,80 @@
                 <a:ea typeface="Malgun Gothic" pitchFamily="34" charset="-122"/>
                 <a:cs typeface="Malgun Gothic" pitchFamily="34" charset="-120"/>
               </a:rPr>
-              <a:t>3. 기사 선택</a:t>
-            </a:r>
-            <a:endParaRPr lang="en-US" sz="1550" dirty="0"/>
-          </a:p>
-        </p:txBody>
-      </p:sp>
-      <p:sp>
-        <p:nvSpPr>
-          <p:cNvPr id="19" name="Text 14"/>
-          <p:cNvSpPr/>
-          <p:nvPr/>
-        </p:nvSpPr>
-        <p:spPr>
-          <a:xfrm>
-            <a:off x="6437376" y="3154680"/>
-            <a:ext cx="2029968" cy="1097280"/>
-          </a:xfrm>
-          <a:prstGeom prst="rect">
-            <a:avLst/>
-          </a:prstGeom>
-          <a:noFill/>
-          <a:ln/>
-        </p:spPr>
-        <p:txBody>
-          <a:bodyPr wrap="square" lIns="0" tIns="0" rIns="0" bIns="0" rtlCol="0" anchor="ctr"/>
-          <a:lstStyle/>
-          <a:p>
-            <a:pPr algn="ctr" indent="0" marL="0">
+              <a:t>생각 표현</a:t>
+            </a:r>
+            <a:endParaRPr lang="en-US" sz="1700" dirty="0"/>
+          </a:p>
+        </p:txBody>
+      </p:sp>
+      <p:sp>
+        <p:nvSpPr>
+          <p:cNvPr id="24" name="Text 19"/>
+          <p:cNvSpPr/>
+          <p:nvPr/>
+        </p:nvSpPr>
+        <p:spPr>
+          <a:xfrm>
+            <a:off x="10378440" y="2139696"/>
+            <a:ext cx="777240" cy="347472"/>
+          </a:xfrm>
+          <a:prstGeom prst="rect">
+            <a:avLst/>
+          </a:prstGeom>
+          <a:noFill/>
+          <a:ln/>
+        </p:spPr>
+        <p:txBody>
+          <a:bodyPr wrap="square" lIns="0" tIns="0" rIns="0" bIns="0" rtlCol="0" anchor="ctr"/>
+          <a:lstStyle/>
+          <a:p>
+            <a:pPr algn="r" indent="0" marL="0">
+              <a:buNone/>
+            </a:pPr>
+            <a:r>
+              <a:rPr lang="en-US" sz="1200" b="1" dirty="0">
+                <a:solidFill>
+                  <a:srgbClr val="2C8A5B"/>
+                </a:solidFill>
+                <a:latin typeface="Malgun Gothic" pitchFamily="34" charset="0"/>
+                <a:ea typeface="Malgun Gothic" pitchFamily="34" charset="-122"/>
+                <a:cs typeface="Malgun Gothic" pitchFamily="34" charset="-120"/>
+              </a:rPr>
+              <a:t>0~5점</a:t>
+            </a:r>
+            <a:endParaRPr lang="en-US" sz="1200" dirty="0"/>
+          </a:p>
+        </p:txBody>
+      </p:sp>
+      <p:sp>
+        <p:nvSpPr>
+          <p:cNvPr id="25" name="Text 20"/>
+          <p:cNvSpPr/>
+          <p:nvPr/>
+        </p:nvSpPr>
+        <p:spPr>
+          <a:xfrm>
+            <a:off x="8339328" y="2788920"/>
+            <a:ext cx="2706624" cy="868680"/>
+          </a:xfrm>
+          <a:prstGeom prst="rect">
+            <a:avLst/>
+          </a:prstGeom>
+          <a:noFill/>
+          <a:ln/>
+        </p:spPr>
+        <p:txBody>
+          <a:bodyPr wrap="square" lIns="0" tIns="0" rIns="0" bIns="0" rtlCol="0" anchor="ctr"/>
+          <a:lstStyle/>
+          <a:p>
+            <a:pPr indent="0" marL="0">
               <a:lnSpc>
                 <a:spcPct val="115000"/>
               </a:lnSpc>
               <a:buNone/>
             </a:pPr>
             <a:r>
-              <a:rPr lang="en-US" sz="1200" dirty="0">
+              <a:rPr lang="en-US" sz="1300" dirty="0">
                 <a:solidFill>
                   <a:srgbClr val="26343B"/>
                 </a:solidFill>
@@ -7183,65 +7575,107 @@
                 <a:ea typeface="Malgun Gothic" pitchFamily="34" charset="-122"/>
                 <a:cs typeface="Malgun Gothic" pitchFamily="34" charset="-120"/>
               </a:rPr>
-              <a:t>내가 읽은 기사를 목록에서 골라요.</a:t>
-            </a:r>
-            <a:endParaRPr lang="en-US" sz="1200" dirty="0"/>
-          </a:p>
-        </p:txBody>
-      </p:sp>
-      <p:sp>
-        <p:nvSpPr>
-          <p:cNvPr id="20" name="Text 15"/>
-          <p:cNvSpPr/>
-          <p:nvPr/>
-        </p:nvSpPr>
-        <p:spPr>
-          <a:xfrm>
-            <a:off x="8613648" y="2743200"/>
-            <a:ext cx="365760" cy="457200"/>
-          </a:xfrm>
-          <a:prstGeom prst="rect">
-            <a:avLst/>
-          </a:prstGeom>
-          <a:noFill/>
-          <a:ln/>
-        </p:spPr>
-        <p:txBody>
-          <a:bodyPr wrap="square" lIns="0" tIns="0" rIns="0" bIns="0" rtlCol="0" anchor="ctr"/>
-          <a:lstStyle/>
-          <a:p>
-            <a:pPr algn="ctr" indent="0" marL="0">
-              <a:buNone/>
-            </a:pPr>
-            <a:r>
-              <a:rPr lang="en-US" sz="2000" b="1" dirty="0">
-                <a:solidFill>
-                  <a:srgbClr val="5E7078"/>
-                </a:solidFill>
-                <a:latin typeface="Malgun Gothic" pitchFamily="34" charset="0"/>
-                <a:ea typeface="Malgun Gothic" pitchFamily="34" charset="-122"/>
-                <a:cs typeface="Malgun Gothic" pitchFamily="34" charset="-120"/>
-              </a:rPr>
-              <a:t>→</a:t>
-            </a:r>
-            <a:endParaRPr lang="en-US" sz="2000" dirty="0"/>
-          </a:p>
-        </p:txBody>
-      </p:sp>
-      <p:sp>
-        <p:nvSpPr>
-          <p:cNvPr id="21" name="Shape 16"/>
-          <p:cNvSpPr/>
-          <p:nvPr/>
-        </p:nvSpPr>
-        <p:spPr>
-          <a:xfrm>
-            <a:off x="8915400" y="1554480"/>
-            <a:ext cx="2468880" cy="2834640"/>
+              <a:t>이해하기 쉽고 존중하는 말로 표현했나요?</a:t>
+            </a:r>
+            <a:endParaRPr lang="en-US" sz="1300" dirty="0"/>
+          </a:p>
+        </p:txBody>
+      </p:sp>
+      <p:sp>
+        <p:nvSpPr>
+          <p:cNvPr id="26" name="Shape 21"/>
+          <p:cNvSpPr/>
+          <p:nvPr/>
+        </p:nvSpPr>
+        <p:spPr>
+          <a:xfrm>
+            <a:off x="8302752" y="3703320"/>
+            <a:ext cx="2779776" cy="1170432"/>
           </a:xfrm>
           <a:prstGeom prst="roundRect">
             <a:avLst>
-              <a:gd name="adj" fmla="val 5185"/>
+              <a:gd name="adj" fmla="val 7813"/>
+            </a:avLst>
+          </a:prstGeom>
+          <a:solidFill>
+            <a:srgbClr val="FFFFFF"/>
+          </a:solidFill>
+          <a:ln/>
+        </p:spPr>
+      </p:sp>
+      <p:sp>
+        <p:nvSpPr>
+          <p:cNvPr id="27" name="Text 22"/>
+          <p:cNvSpPr/>
+          <p:nvPr/>
+        </p:nvSpPr>
+        <p:spPr>
+          <a:xfrm>
+            <a:off x="8449056" y="3803904"/>
+            <a:ext cx="2487168" cy="1005840"/>
+          </a:xfrm>
+          <a:prstGeom prst="rect">
+            <a:avLst/>
+          </a:prstGeom>
+          <a:noFill/>
+          <a:ln/>
+        </p:spPr>
+        <p:txBody>
+          <a:bodyPr wrap="square" lIns="0" tIns="0" rIns="0" bIns="0" rtlCol="0" anchor="ctr"/>
+          <a:lstStyle/>
+          <a:p>
+            <a:pPr indent="0" marL="0">
+              <a:lnSpc>
+                <a:spcPct val="115000"/>
+              </a:lnSpc>
+              <a:buNone/>
+            </a:pPr>
+            <a:r>
+              <a:rPr lang="en-US" sz="1150" b="1" dirty="0">
+                <a:solidFill>
+                  <a:srgbClr val="B8860B"/>
+                </a:solidFill>
+                <a:latin typeface="Malgun Gothic" pitchFamily="34" charset="0"/>
+                <a:ea typeface="Malgun Gothic" pitchFamily="34" charset="-122"/>
+                <a:cs typeface="Malgun Gothic" pitchFamily="34" charset="-120"/>
+              </a:rPr>
+              <a:t>⭐ 5점의 모습  </a:t>
+            </a:r>
+            <a:pPr indent="0" marL="0">
+              <a:lnSpc>
+                <a:spcPct val="115000"/>
+              </a:lnSpc>
+              <a:buNone/>
+            </a:pPr>
+            <a:r>
+              <a:rPr lang="en-US" sz="1150" dirty="0">
+                <a:solidFill>
+                  <a:srgbClr val="26343B"/>
+                </a:solidFill>
+                <a:latin typeface="Malgun Gothic" pitchFamily="34" charset="0"/>
+                <a:ea typeface="Malgun Gothic" pitchFamily="34" charset="-122"/>
+                <a:cs typeface="Malgun Gothic" pitchFamily="34" charset="-120"/>
+              </a:rPr>
+              <a:t>주장이 분명하고, 질문이나 대안으로 읽는 사람의 생각을 넓히면 최고!</a:t>
+            </a:r>
+            <a:endParaRPr lang="en-US" sz="1150" dirty="0"/>
+          </a:p>
+        </p:txBody>
+      </p:sp>
+      <p:sp>
+        <p:nvSpPr>
+          <p:cNvPr id="28" name="Shape 23"/>
+          <p:cNvSpPr/>
+          <p:nvPr/>
+        </p:nvSpPr>
+        <p:spPr>
+          <a:xfrm>
+            <a:off x="822960" y="5349240"/>
+            <a:ext cx="10515600" cy="1051560"/>
+          </a:xfrm>
+          <a:prstGeom prst="roundRect">
+            <a:avLst>
+              <a:gd name="adj" fmla="val 10435"/>
             </a:avLst>
           </a:prstGeom>
           <a:solidFill>
@@ -7252,116 +7686,44 @@
       </p:sp>
       <p:sp>
         <p:nvSpPr>
-          <p:cNvPr id="22" name="Shape 17"/>
-          <p:cNvSpPr/>
-          <p:nvPr/>
-        </p:nvSpPr>
-        <p:spPr>
-          <a:xfrm>
-            <a:off x="9784080" y="1783080"/>
-            <a:ext cx="731520" cy="731520"/>
-          </a:xfrm>
-          <a:prstGeom prst="ellipse">
-            <a:avLst/>
-          </a:prstGeom>
-          <a:solidFill>
-            <a:srgbClr val="FFFFFF"/>
-          </a:solidFill>
-          <a:ln/>
-        </p:spPr>
-      </p:sp>
-      <p:pic>
-        <p:nvPicPr>
-          <p:cNvPr id="23" name="Image 3" descr="preencoded.png">    </p:cNvPr>
-          <p:cNvPicPr>
-            <a:picLocks noChangeAspect="1"/>
-          </p:cNvPicPr>
-          <p:nvPr/>
-        </p:nvPicPr>
-        <p:blipFill>
-          <a:blip r:embed="rId4"/>
-          <a:stretch>
-            <a:fillRect/>
-          </a:stretch>
-        </p:blipFill>
-        <p:spPr>
-          <a:xfrm>
-            <a:off x="9959645" y="1958645"/>
-            <a:ext cx="380390" cy="380390"/>
-          </a:xfrm>
-          <a:prstGeom prst="rect">
-            <a:avLst/>
-          </a:prstGeom>
-        </p:spPr>
-      </p:pic>
-      <p:sp>
-        <p:nvSpPr>
-          <p:cNvPr id="24" name="Text 18"/>
-          <p:cNvSpPr/>
-          <p:nvPr/>
-        </p:nvSpPr>
-        <p:spPr>
-          <a:xfrm>
-            <a:off x="9098280" y="2697480"/>
-            <a:ext cx="2103120" cy="411480"/>
-          </a:xfrm>
-          <a:prstGeom prst="rect">
-            <a:avLst/>
-          </a:prstGeom>
-          <a:noFill/>
-          <a:ln/>
-        </p:spPr>
-        <p:txBody>
-          <a:bodyPr wrap="square" lIns="0" tIns="0" rIns="0" bIns="0" rtlCol="0" anchor="ctr"/>
-          <a:lstStyle/>
-          <a:p>
-            <a:pPr algn="ctr" indent="0" marL="0">
-              <a:buNone/>
-            </a:pPr>
-            <a:r>
-              <a:rPr lang="en-US" sz="1550" b="1" dirty="0">
-                <a:solidFill>
-                  <a:srgbClr val="065A6E"/>
-                </a:solidFill>
-                <a:latin typeface="Malgun Gothic" pitchFamily="34" charset="0"/>
-                <a:ea typeface="Malgun Gothic" pitchFamily="34" charset="-122"/>
-                <a:cs typeface="Malgun Gothic" pitchFamily="34" charset="-120"/>
-              </a:rPr>
-              <a:t>4. 의견 쓰고 제출</a:t>
-            </a:r>
-            <a:endParaRPr lang="en-US" sz="1550" dirty="0"/>
-          </a:p>
-        </p:txBody>
-      </p:sp>
-      <p:sp>
-        <p:nvSpPr>
-          <p:cNvPr id="25" name="Text 19"/>
-          <p:cNvSpPr/>
-          <p:nvPr/>
-        </p:nvSpPr>
-        <p:spPr>
-          <a:xfrm>
-            <a:off x="9134856" y="3154680"/>
-            <a:ext cx="2029968" cy="1097280"/>
-          </a:xfrm>
-          <a:prstGeom prst="rect">
-            <a:avLst/>
-          </a:prstGeom>
-          <a:noFill/>
-          <a:ln/>
-        </p:spPr>
-        <p:txBody>
-          <a:bodyPr wrap="square" lIns="0" tIns="0" rIns="0" bIns="0" rtlCol="0" anchor="ctr"/>
-          <a:lstStyle/>
-          <a:p>
-            <a:pPr algn="ctr" indent="0" marL="0">
-              <a:lnSpc>
-                <a:spcPct val="115000"/>
-              </a:lnSpc>
-              <a:buNone/>
-            </a:pPr>
-            <a:r>
-              <a:rPr lang="en-US" sz="1200" dirty="0">
+          <p:cNvPr id="29" name="Text 24"/>
+          <p:cNvSpPr/>
+          <p:nvPr/>
+        </p:nvSpPr>
+        <p:spPr>
+          <a:xfrm>
+            <a:off x="1143000" y="5669280"/>
+            <a:ext cx="9875520" cy="502920"/>
+          </a:xfrm>
+          <a:prstGeom prst="rect">
+            <a:avLst/>
+          </a:prstGeom>
+          <a:noFill/>
+          <a:ln/>
+        </p:spPr>
+        <p:txBody>
+          <a:bodyPr wrap="square" lIns="0" tIns="0" rIns="0" bIns="0" rtlCol="0" anchor="ctr"/>
+          <a:lstStyle/>
+          <a:p>
+            <a:pPr indent="0" marL="0">
+              <a:buNone/>
+            </a:pPr>
+            <a:r>
+              <a:rPr lang="en-US" sz="1450" b="1" dirty="0">
+                <a:solidFill>
+                  <a:srgbClr val="028090"/>
+                </a:solidFill>
+                <a:latin typeface="Malgun Gothic" pitchFamily="34" charset="0"/>
+                <a:ea typeface="Malgun Gothic" pitchFamily="34" charset="-122"/>
+                <a:cs typeface="Malgun Gothic" pitchFamily="34" charset="-120"/>
+              </a:rPr>
+              <a:t>점수가 끝이 아니에요.  </a:t>
+            </a:r>
+            <a:pPr indent="0" marL="0">
+              <a:buNone/>
+            </a:pPr>
+            <a:r>
+              <a:rPr lang="en-US" sz="1450" dirty="0">
                 <a:solidFill>
                   <a:srgbClr val="26343B"/>
                 </a:solidFill>
@@ -7369,153 +7731,9 @@
                 <a:ea typeface="Malgun Gothic" pitchFamily="34" charset="-122"/>
                 <a:cs typeface="Malgun Gothic" pitchFamily="34" charset="-120"/>
               </a:rPr>
-              <a:t>완성한 의견 글을 붙여 넣고 제출 버튼을 눌러요.</a:t>
-            </a:r>
-            <a:endParaRPr lang="en-US" sz="1200" dirty="0"/>
-          </a:p>
-        </p:txBody>
-      </p:sp>
-      <p:sp>
-        <p:nvSpPr>
-          <p:cNvPr id="26" name="Shape 20"/>
-          <p:cNvSpPr/>
-          <p:nvPr/>
-        </p:nvSpPr>
-        <p:spPr>
-          <a:xfrm>
-            <a:off x="822960" y="4754880"/>
-            <a:ext cx="10515600" cy="1371600"/>
-          </a:xfrm>
-          <a:prstGeom prst="roundRect">
-            <a:avLst>
-              <a:gd name="adj" fmla="val 8000"/>
-            </a:avLst>
-          </a:prstGeom>
-          <a:solidFill>
-            <a:srgbClr val="FFF6DE"/>
-          </a:solidFill>
-          <a:ln/>
-        </p:spPr>
-      </p:sp>
-      <p:sp>
-        <p:nvSpPr>
-          <p:cNvPr id="27" name="Shape 21"/>
-          <p:cNvSpPr/>
-          <p:nvPr/>
-        </p:nvSpPr>
-        <p:spPr>
-          <a:xfrm>
-            <a:off x="1051560" y="5029200"/>
-            <a:ext cx="566928" cy="566928"/>
-          </a:xfrm>
-          <a:prstGeom prst="ellipse">
-            <a:avLst/>
-          </a:prstGeom>
-          <a:solidFill>
-            <a:srgbClr val="FFFFFF"/>
-          </a:solidFill>
-          <a:ln/>
-        </p:spPr>
-      </p:sp>
-      <p:pic>
-        <p:nvPicPr>
-          <p:cNvPr id="28" name="Image 4" descr="preencoded.png">    </p:cNvPr>
-          <p:cNvPicPr>
-            <a:picLocks noChangeAspect="1"/>
-          </p:cNvPicPr>
-          <p:nvPr/>
-        </p:nvPicPr>
-        <p:blipFill>
-          <a:blip r:embed="rId5"/>
-          <a:stretch>
-            <a:fillRect/>
-          </a:stretch>
-        </p:blipFill>
-        <p:spPr>
-          <a:xfrm>
-            <a:off x="1198961" y="5176601"/>
-            <a:ext cx="272125" cy="272125"/>
-          </a:xfrm>
-          <a:prstGeom prst="rect">
-            <a:avLst/>
-          </a:prstGeom>
-        </p:spPr>
-      </p:pic>
-      <p:sp>
-        <p:nvSpPr>
-          <p:cNvPr id="29" name="Text 22"/>
-          <p:cNvSpPr/>
-          <p:nvPr/>
-        </p:nvSpPr>
-        <p:spPr>
-          <a:xfrm>
-            <a:off x="1828800" y="4956048"/>
-            <a:ext cx="9326880" cy="411480"/>
-          </a:xfrm>
-          <a:prstGeom prst="rect">
-            <a:avLst/>
-          </a:prstGeom>
-          <a:noFill/>
-          <a:ln/>
-        </p:spPr>
-        <p:txBody>
-          <a:bodyPr wrap="square" lIns="0" tIns="0" rIns="0" bIns="0" rtlCol="0" anchor="ctr"/>
-          <a:lstStyle/>
-          <a:p>
-            <a:pPr indent="0" marL="0">
-              <a:buNone/>
-            </a:pPr>
-            <a:r>
-              <a:rPr lang="en-US" sz="1550" b="1" dirty="0">
-                <a:solidFill>
-                  <a:srgbClr val="8A6100"/>
-                </a:solidFill>
-                <a:latin typeface="Malgun Gothic" pitchFamily="34" charset="0"/>
-                <a:ea typeface="Malgun Gothic" pitchFamily="34" charset="-122"/>
-                <a:cs typeface="Malgun Gothic" pitchFamily="34" charset="-120"/>
-              </a:rPr>
-              <a:t>제출 전에 꼭 확인!</a:t>
-            </a:r>
-            <a:endParaRPr lang="en-US" sz="1550" dirty="0"/>
-          </a:p>
-        </p:txBody>
-      </p:sp>
-      <p:sp>
-        <p:nvSpPr>
-          <p:cNvPr id="30" name="Text 23"/>
-          <p:cNvSpPr/>
-          <p:nvPr/>
-        </p:nvSpPr>
-        <p:spPr>
-          <a:xfrm>
-            <a:off x="1828800" y="5394960"/>
-            <a:ext cx="9326880" cy="548640"/>
-          </a:xfrm>
-          <a:prstGeom prst="rect">
-            <a:avLst/>
-          </a:prstGeom>
-          <a:noFill/>
-          <a:ln/>
-        </p:spPr>
-        <p:txBody>
-          <a:bodyPr wrap="square" lIns="0" tIns="0" rIns="0" bIns="0" rtlCol="0" anchor="ctr"/>
-          <a:lstStyle/>
-          <a:p>
-            <a:pPr indent="0" marL="0">
-              <a:buNone/>
-            </a:pPr>
-            <a:r>
-              <a:rPr lang="en-US" sz="1350" dirty="0">
-                <a:solidFill>
-                  <a:srgbClr val="26343B"/>
-                </a:solidFill>
-                <a:latin typeface="Malgun Gothic" pitchFamily="34" charset="0"/>
-                <a:ea typeface="Malgun Gothic" pitchFamily="34" charset="-122"/>
-                <a:cs typeface="Malgun Gothic" pitchFamily="34" charset="-120"/>
-              </a:rPr>
-              <a:t>① 자기점검 다섯 가지를 통과했나요?   ② 내 번호와 기사를 바르게 골랐나요?  (잘못 고르면 제출해도 ‘미제출’로 보여요)</a:t>
-            </a:r>
-            <a:endParaRPr lang="en-US" sz="1350" dirty="0"/>
+              <a:t>선생님이 강점과 피드백, 그리고 다음 글에서 도전할 한 가지(평가 포워드)를 알려 줘요. 다음 글에서 꼭 시도해 봐요!</a:t>
+            </a:r>
+            <a:endParaRPr lang="en-US" sz="1450" dirty="0"/>
           </a:p>
         </p:txBody>
       </p:sp>
@@ -7530,6 +7748,926 @@
 <file path=ppt/slides/slide16.xml><?xml version="1.0" encoding="utf-8"?>
 <p:sld xmlns:a="http://schemas.openxmlformats.org/drawingml/2006/main" xmlns:r="http://schemas.openxmlformats.org/officeDocument/2006/relationships" xmlns:p="http://schemas.openxmlformats.org/presentationml/2006/main">
   <p:cSld name="Slide 16">
+    <p:bg>
+      <p:bgPr>
+        <a:solidFill>
+          <a:srgbClr val="FFFFFF"/>
+        </a:solidFill>
+      </p:bgPr>
+    </p:bg>
+    <p:spTree>
+      <p:nvGrpSpPr>
+        <p:cNvPr id="1" name=""/>
+        <p:cNvGrpSpPr/>
+        <p:nvPr/>
+      </p:nvGrpSpPr>
+      <p:grpSpPr>
+        <a:xfrm>
+          <a:off x="0" y="0"/>
+          <a:ext cx="0" cy="0"/>
+          <a:chOff x="0" y="0"/>
+          <a:chExt cx="0" cy="0"/>
+        </a:xfrm>
+      </p:grpSpPr>
+      <p:sp>
+        <p:nvSpPr>
+          <p:cNvPr id="2" name="Text 0"/>
+          <p:cNvSpPr/>
+          <p:nvPr/>
+        </p:nvSpPr>
+        <p:spPr>
+          <a:xfrm>
+            <a:off x="822960" y="502920"/>
+            <a:ext cx="10515600" cy="594360"/>
+          </a:xfrm>
+          <a:prstGeom prst="rect">
+            <a:avLst/>
+          </a:prstGeom>
+          <a:noFill/>
+          <a:ln/>
+        </p:spPr>
+        <p:txBody>
+          <a:bodyPr wrap="square" lIns="0" tIns="0" rIns="0" bIns="0" rtlCol="0" anchor="ctr"/>
+          <a:lstStyle/>
+          <a:p>
+            <a:pPr indent="0" marL="0">
+              <a:buNone/>
+            </a:pPr>
+            <a:r>
+              <a:rPr lang="en-US" sz="3200" b="1" dirty="0">
+                <a:solidFill>
+                  <a:srgbClr val="065A6E"/>
+                </a:solidFill>
+                <a:latin typeface="Malgun Gothic" pitchFamily="34" charset="0"/>
+                <a:ea typeface="Malgun Gothic" pitchFamily="34" charset="-122"/>
+                <a:cs typeface="Malgun Gothic" pitchFamily="34" charset="-120"/>
+              </a:rPr>
+              <a:t>4단계 · 노션 폼으로 제출해요</a:t>
+            </a:r>
+            <a:endParaRPr lang="en-US" sz="3200" dirty="0"/>
+          </a:p>
+        </p:txBody>
+      </p:sp>
+      <p:sp>
+        <p:nvSpPr>
+          <p:cNvPr id="3" name="Shape 1"/>
+          <p:cNvSpPr/>
+          <p:nvPr/>
+        </p:nvSpPr>
+        <p:spPr>
+          <a:xfrm>
+            <a:off x="822960" y="1554480"/>
+            <a:ext cx="2468880" cy="2834640"/>
+          </a:xfrm>
+          <a:prstGeom prst="roundRect">
+            <a:avLst>
+              <a:gd name="adj" fmla="val 5185"/>
+            </a:avLst>
+          </a:prstGeom>
+          <a:solidFill>
+            <a:srgbClr val="E3F4F2"/>
+          </a:solidFill>
+          <a:ln/>
+        </p:spPr>
+      </p:sp>
+      <p:sp>
+        <p:nvSpPr>
+          <p:cNvPr id="4" name="Shape 2"/>
+          <p:cNvSpPr/>
+          <p:nvPr/>
+        </p:nvSpPr>
+        <p:spPr>
+          <a:xfrm>
+            <a:off x="1691640" y="1783080"/>
+            <a:ext cx="731520" cy="731520"/>
+          </a:xfrm>
+          <a:prstGeom prst="ellipse">
+            <a:avLst/>
+          </a:prstGeom>
+          <a:solidFill>
+            <a:srgbClr val="FFFFFF"/>
+          </a:solidFill>
+          <a:ln/>
+        </p:spPr>
+      </p:sp>
+      <p:pic>
+        <p:nvPicPr>
+          <p:cNvPr id="5" name="Image 0" descr="preencoded.png">    </p:cNvPr>
+          <p:cNvPicPr>
+            <a:picLocks noChangeAspect="1"/>
+          </p:cNvPicPr>
+          <p:nvPr/>
+        </p:nvPicPr>
+        <p:blipFill>
+          <a:blip r:embed="rId1"/>
+          <a:stretch>
+            <a:fillRect/>
+          </a:stretch>
+        </p:blipFill>
+        <p:spPr>
+          <a:xfrm>
+            <a:off x="1867205" y="1958645"/>
+            <a:ext cx="380390" cy="380390"/>
+          </a:xfrm>
+          <a:prstGeom prst="rect">
+            <a:avLst/>
+          </a:prstGeom>
+        </p:spPr>
+      </p:pic>
+      <p:sp>
+        <p:nvSpPr>
+          <p:cNvPr id="6" name="Text 3"/>
+          <p:cNvSpPr/>
+          <p:nvPr/>
+        </p:nvSpPr>
+        <p:spPr>
+          <a:xfrm>
+            <a:off x="1005840" y="2697480"/>
+            <a:ext cx="2103120" cy="411480"/>
+          </a:xfrm>
+          <a:prstGeom prst="rect">
+            <a:avLst/>
+          </a:prstGeom>
+          <a:noFill/>
+          <a:ln/>
+        </p:spPr>
+        <p:txBody>
+          <a:bodyPr wrap="square" lIns="0" tIns="0" rIns="0" bIns="0" rtlCol="0" anchor="ctr"/>
+          <a:lstStyle/>
+          <a:p>
+            <a:pPr algn="ctr" indent="0" marL="0">
+              <a:buNone/>
+            </a:pPr>
+            <a:r>
+              <a:rPr lang="en-US" sz="1550" b="1" dirty="0">
+                <a:solidFill>
+                  <a:srgbClr val="065A6E"/>
+                </a:solidFill>
+                <a:latin typeface="Malgun Gothic" pitchFamily="34" charset="0"/>
+                <a:ea typeface="Malgun Gothic" pitchFamily="34" charset="-122"/>
+                <a:cs typeface="Malgun Gothic" pitchFamily="34" charset="-120"/>
+              </a:rPr>
+              <a:t>1. 폼 열기</a:t>
+            </a:r>
+            <a:endParaRPr lang="en-US" sz="1550" dirty="0"/>
+          </a:p>
+        </p:txBody>
+      </p:sp>
+      <p:sp>
+        <p:nvSpPr>
+          <p:cNvPr id="7" name="Text 4"/>
+          <p:cNvSpPr/>
+          <p:nvPr/>
+        </p:nvSpPr>
+        <p:spPr>
+          <a:xfrm>
+            <a:off x="1042416" y="3154680"/>
+            <a:ext cx="2029968" cy="1097280"/>
+          </a:xfrm>
+          <a:prstGeom prst="rect">
+            <a:avLst/>
+          </a:prstGeom>
+          <a:noFill/>
+          <a:ln/>
+        </p:spPr>
+        <p:txBody>
+          <a:bodyPr wrap="square" lIns="0" tIns="0" rIns="0" bIns="0" rtlCol="0" anchor="ctr"/>
+          <a:lstStyle/>
+          <a:p>
+            <a:pPr algn="ctr" indent="0" marL="0">
+              <a:lnSpc>
+                <a:spcPct val="115000"/>
+              </a:lnSpc>
+              <a:buNone/>
+            </a:pPr>
+            <a:r>
+              <a:rPr lang="en-US" sz="1200" dirty="0">
+                <a:solidFill>
+                  <a:srgbClr val="26343B"/>
+                </a:solidFill>
+                <a:latin typeface="Malgun Gothic" pitchFamily="34" charset="0"/>
+                <a:ea typeface="Malgun Gothic" pitchFamily="34" charset="-122"/>
+                <a:cs typeface="Malgun Gothic" pitchFamily="34" charset="-120"/>
+              </a:rPr>
+              <a:t>기사 페이지에 있는 ‘의견쓰기’ 폼을 열어요.</a:t>
+            </a:r>
+            <a:endParaRPr lang="en-US" sz="1200" dirty="0"/>
+          </a:p>
+        </p:txBody>
+      </p:sp>
+      <p:sp>
+        <p:nvSpPr>
+          <p:cNvPr id="8" name="Text 5"/>
+          <p:cNvSpPr/>
+          <p:nvPr/>
+        </p:nvSpPr>
+        <p:spPr>
+          <a:xfrm>
+            <a:off x="3218688" y="2743200"/>
+            <a:ext cx="365760" cy="457200"/>
+          </a:xfrm>
+          <a:prstGeom prst="rect">
+            <a:avLst/>
+          </a:prstGeom>
+          <a:noFill/>
+          <a:ln/>
+        </p:spPr>
+        <p:txBody>
+          <a:bodyPr wrap="square" lIns="0" tIns="0" rIns="0" bIns="0" rtlCol="0" anchor="ctr"/>
+          <a:lstStyle/>
+          <a:p>
+            <a:pPr algn="ctr" indent="0" marL="0">
+              <a:buNone/>
+            </a:pPr>
+            <a:r>
+              <a:rPr lang="en-US" sz="2000" b="1" dirty="0">
+                <a:solidFill>
+                  <a:srgbClr val="5E7078"/>
+                </a:solidFill>
+                <a:latin typeface="Malgun Gothic" pitchFamily="34" charset="0"/>
+                <a:ea typeface="Malgun Gothic" pitchFamily="34" charset="-122"/>
+                <a:cs typeface="Malgun Gothic" pitchFamily="34" charset="-120"/>
+              </a:rPr>
+              <a:t>→</a:t>
+            </a:r>
+            <a:endParaRPr lang="en-US" sz="2000" dirty="0"/>
+          </a:p>
+        </p:txBody>
+      </p:sp>
+      <p:sp>
+        <p:nvSpPr>
+          <p:cNvPr id="9" name="Shape 6"/>
+          <p:cNvSpPr/>
+          <p:nvPr/>
+        </p:nvSpPr>
+        <p:spPr>
+          <a:xfrm>
+            <a:off x="3520440" y="1554480"/>
+            <a:ext cx="2468880" cy="2834640"/>
+          </a:xfrm>
+          <a:prstGeom prst="roundRect">
+            <a:avLst>
+              <a:gd name="adj" fmla="val 5185"/>
+            </a:avLst>
+          </a:prstGeom>
+          <a:solidFill>
+            <a:srgbClr val="E3F4F2"/>
+          </a:solidFill>
+          <a:ln/>
+        </p:spPr>
+      </p:sp>
+      <p:sp>
+        <p:nvSpPr>
+          <p:cNvPr id="10" name="Shape 7"/>
+          <p:cNvSpPr/>
+          <p:nvPr/>
+        </p:nvSpPr>
+        <p:spPr>
+          <a:xfrm>
+            <a:off x="4389120" y="1783080"/>
+            <a:ext cx="731520" cy="731520"/>
+          </a:xfrm>
+          <a:prstGeom prst="ellipse">
+            <a:avLst/>
+          </a:prstGeom>
+          <a:solidFill>
+            <a:srgbClr val="FFFFFF"/>
+          </a:solidFill>
+          <a:ln/>
+        </p:spPr>
+      </p:sp>
+      <p:pic>
+        <p:nvPicPr>
+          <p:cNvPr id="11" name="Image 1" descr="preencoded.png">    </p:cNvPr>
+          <p:cNvPicPr>
+            <a:picLocks noChangeAspect="1"/>
+          </p:cNvPicPr>
+          <p:nvPr/>
+        </p:nvPicPr>
+        <p:blipFill>
+          <a:blip r:embed="rId2"/>
+          <a:stretch>
+            <a:fillRect/>
+          </a:stretch>
+        </p:blipFill>
+        <p:spPr>
+          <a:xfrm>
+            <a:off x="4564685" y="1958645"/>
+            <a:ext cx="380390" cy="380390"/>
+          </a:xfrm>
+          <a:prstGeom prst="rect">
+            <a:avLst/>
+          </a:prstGeom>
+        </p:spPr>
+      </p:pic>
+      <p:sp>
+        <p:nvSpPr>
+          <p:cNvPr id="12" name="Text 8"/>
+          <p:cNvSpPr/>
+          <p:nvPr/>
+        </p:nvSpPr>
+        <p:spPr>
+          <a:xfrm>
+            <a:off x="3703320" y="2697480"/>
+            <a:ext cx="2103120" cy="411480"/>
+          </a:xfrm>
+          <a:prstGeom prst="rect">
+            <a:avLst/>
+          </a:prstGeom>
+          <a:noFill/>
+          <a:ln/>
+        </p:spPr>
+        <p:txBody>
+          <a:bodyPr wrap="square" lIns="0" tIns="0" rIns="0" bIns="0" rtlCol="0" anchor="ctr"/>
+          <a:lstStyle/>
+          <a:p>
+            <a:pPr algn="ctr" indent="0" marL="0">
+              <a:buNone/>
+            </a:pPr>
+            <a:r>
+              <a:rPr lang="en-US" sz="1550" b="1" dirty="0">
+                <a:solidFill>
+                  <a:srgbClr val="065A6E"/>
+                </a:solidFill>
+                <a:latin typeface="Malgun Gothic" pitchFamily="34" charset="0"/>
+                <a:ea typeface="Malgun Gothic" pitchFamily="34" charset="-122"/>
+                <a:cs typeface="Malgun Gothic" pitchFamily="34" charset="-120"/>
+              </a:rPr>
+              <a:t>2. 내 번호 선택</a:t>
+            </a:r>
+            <a:endParaRPr lang="en-US" sz="1550" dirty="0"/>
+          </a:p>
+        </p:txBody>
+      </p:sp>
+      <p:sp>
+        <p:nvSpPr>
+          <p:cNvPr id="13" name="Text 9"/>
+          <p:cNvSpPr/>
+          <p:nvPr/>
+        </p:nvSpPr>
+        <p:spPr>
+          <a:xfrm>
+            <a:off x="3739896" y="3154680"/>
+            <a:ext cx="2029968" cy="1097280"/>
+          </a:xfrm>
+          <a:prstGeom prst="rect">
+            <a:avLst/>
+          </a:prstGeom>
+          <a:noFill/>
+          <a:ln/>
+        </p:spPr>
+        <p:txBody>
+          <a:bodyPr wrap="square" lIns="0" tIns="0" rIns="0" bIns="0" rtlCol="0" anchor="ctr"/>
+          <a:lstStyle/>
+          <a:p>
+            <a:pPr algn="ctr" indent="0" marL="0">
+              <a:lnSpc>
+                <a:spcPct val="115000"/>
+              </a:lnSpc>
+              <a:buNone/>
+            </a:pPr>
+            <a:r>
+              <a:rPr lang="en-US" sz="1200" dirty="0">
+                <a:solidFill>
+                  <a:srgbClr val="26343B"/>
+                </a:solidFill>
+                <a:latin typeface="Malgun Gothic" pitchFamily="34" charset="0"/>
+                <a:ea typeface="Malgun Gothic" pitchFamily="34" charset="-122"/>
+                <a:cs typeface="Malgun Gothic" pitchFamily="34" charset="-120"/>
+              </a:rPr>
+              <a:t>목록에서 내 학생 번호를 ‘선택’해요. 직접 쓰지 않아요!</a:t>
+            </a:r>
+            <a:endParaRPr lang="en-US" sz="1200" dirty="0"/>
+          </a:p>
+        </p:txBody>
+      </p:sp>
+      <p:sp>
+        <p:nvSpPr>
+          <p:cNvPr id="14" name="Text 10"/>
+          <p:cNvSpPr/>
+          <p:nvPr/>
+        </p:nvSpPr>
+        <p:spPr>
+          <a:xfrm>
+            <a:off x="5916168" y="2743200"/>
+            <a:ext cx="365760" cy="457200"/>
+          </a:xfrm>
+          <a:prstGeom prst="rect">
+            <a:avLst/>
+          </a:prstGeom>
+          <a:noFill/>
+          <a:ln/>
+        </p:spPr>
+        <p:txBody>
+          <a:bodyPr wrap="square" lIns="0" tIns="0" rIns="0" bIns="0" rtlCol="0" anchor="ctr"/>
+          <a:lstStyle/>
+          <a:p>
+            <a:pPr algn="ctr" indent="0" marL="0">
+              <a:buNone/>
+            </a:pPr>
+            <a:r>
+              <a:rPr lang="en-US" sz="2000" b="1" dirty="0">
+                <a:solidFill>
+                  <a:srgbClr val="5E7078"/>
+                </a:solidFill>
+                <a:latin typeface="Malgun Gothic" pitchFamily="34" charset="0"/>
+                <a:ea typeface="Malgun Gothic" pitchFamily="34" charset="-122"/>
+                <a:cs typeface="Malgun Gothic" pitchFamily="34" charset="-120"/>
+              </a:rPr>
+              <a:t>→</a:t>
+            </a:r>
+            <a:endParaRPr lang="en-US" sz="2000" dirty="0"/>
+          </a:p>
+        </p:txBody>
+      </p:sp>
+      <p:sp>
+        <p:nvSpPr>
+          <p:cNvPr id="15" name="Shape 11"/>
+          <p:cNvSpPr/>
+          <p:nvPr/>
+        </p:nvSpPr>
+        <p:spPr>
+          <a:xfrm>
+            <a:off x="6217920" y="1554480"/>
+            <a:ext cx="2468880" cy="2834640"/>
+          </a:xfrm>
+          <a:prstGeom prst="roundRect">
+            <a:avLst>
+              <a:gd name="adj" fmla="val 5185"/>
+            </a:avLst>
+          </a:prstGeom>
+          <a:solidFill>
+            <a:srgbClr val="E3F4F2"/>
+          </a:solidFill>
+          <a:ln/>
+        </p:spPr>
+      </p:sp>
+      <p:sp>
+        <p:nvSpPr>
+          <p:cNvPr id="16" name="Shape 12"/>
+          <p:cNvSpPr/>
+          <p:nvPr/>
+        </p:nvSpPr>
+        <p:spPr>
+          <a:xfrm>
+            <a:off x="7086600" y="1783080"/>
+            <a:ext cx="731520" cy="731520"/>
+          </a:xfrm>
+          <a:prstGeom prst="ellipse">
+            <a:avLst/>
+          </a:prstGeom>
+          <a:solidFill>
+            <a:srgbClr val="FFFFFF"/>
+          </a:solidFill>
+          <a:ln/>
+        </p:spPr>
+      </p:sp>
+      <p:pic>
+        <p:nvPicPr>
+          <p:cNvPr id="17" name="Image 2" descr="preencoded.png">    </p:cNvPr>
+          <p:cNvPicPr>
+            <a:picLocks noChangeAspect="1"/>
+          </p:cNvPicPr>
+          <p:nvPr/>
+        </p:nvPicPr>
+        <p:blipFill>
+          <a:blip r:embed="rId3"/>
+          <a:stretch>
+            <a:fillRect/>
+          </a:stretch>
+        </p:blipFill>
+        <p:spPr>
+          <a:xfrm>
+            <a:off x="7262165" y="1958645"/>
+            <a:ext cx="380390" cy="380390"/>
+          </a:xfrm>
+          <a:prstGeom prst="rect">
+            <a:avLst/>
+          </a:prstGeom>
+        </p:spPr>
+      </p:pic>
+      <p:sp>
+        <p:nvSpPr>
+          <p:cNvPr id="18" name="Text 13"/>
+          <p:cNvSpPr/>
+          <p:nvPr/>
+        </p:nvSpPr>
+        <p:spPr>
+          <a:xfrm>
+            <a:off x="6400800" y="2697480"/>
+            <a:ext cx="2103120" cy="411480"/>
+          </a:xfrm>
+          <a:prstGeom prst="rect">
+            <a:avLst/>
+          </a:prstGeom>
+          <a:noFill/>
+          <a:ln/>
+        </p:spPr>
+        <p:txBody>
+          <a:bodyPr wrap="square" lIns="0" tIns="0" rIns="0" bIns="0" rtlCol="0" anchor="ctr"/>
+          <a:lstStyle/>
+          <a:p>
+            <a:pPr algn="ctr" indent="0" marL="0">
+              <a:buNone/>
+            </a:pPr>
+            <a:r>
+              <a:rPr lang="en-US" sz="1550" b="1" dirty="0">
+                <a:solidFill>
+                  <a:srgbClr val="065A6E"/>
+                </a:solidFill>
+                <a:latin typeface="Malgun Gothic" pitchFamily="34" charset="0"/>
+                <a:ea typeface="Malgun Gothic" pitchFamily="34" charset="-122"/>
+                <a:cs typeface="Malgun Gothic" pitchFamily="34" charset="-120"/>
+              </a:rPr>
+              <a:t>3. 기사 선택</a:t>
+            </a:r>
+            <a:endParaRPr lang="en-US" sz="1550" dirty="0"/>
+          </a:p>
+        </p:txBody>
+      </p:sp>
+      <p:sp>
+        <p:nvSpPr>
+          <p:cNvPr id="19" name="Text 14"/>
+          <p:cNvSpPr/>
+          <p:nvPr/>
+        </p:nvSpPr>
+        <p:spPr>
+          <a:xfrm>
+            <a:off x="6437376" y="3154680"/>
+            <a:ext cx="2029968" cy="1097280"/>
+          </a:xfrm>
+          <a:prstGeom prst="rect">
+            <a:avLst/>
+          </a:prstGeom>
+          <a:noFill/>
+          <a:ln/>
+        </p:spPr>
+        <p:txBody>
+          <a:bodyPr wrap="square" lIns="0" tIns="0" rIns="0" bIns="0" rtlCol="0" anchor="ctr"/>
+          <a:lstStyle/>
+          <a:p>
+            <a:pPr algn="ctr" indent="0" marL="0">
+              <a:lnSpc>
+                <a:spcPct val="115000"/>
+              </a:lnSpc>
+              <a:buNone/>
+            </a:pPr>
+            <a:r>
+              <a:rPr lang="en-US" sz="1200" dirty="0">
+                <a:solidFill>
+                  <a:srgbClr val="26343B"/>
+                </a:solidFill>
+                <a:latin typeface="Malgun Gothic" pitchFamily="34" charset="0"/>
+                <a:ea typeface="Malgun Gothic" pitchFamily="34" charset="-122"/>
+                <a:cs typeface="Malgun Gothic" pitchFamily="34" charset="-120"/>
+              </a:rPr>
+              <a:t>내가 읽은 기사를 목록에서 골라요.</a:t>
+            </a:r>
+            <a:endParaRPr lang="en-US" sz="1200" dirty="0"/>
+          </a:p>
+        </p:txBody>
+      </p:sp>
+      <p:sp>
+        <p:nvSpPr>
+          <p:cNvPr id="20" name="Text 15"/>
+          <p:cNvSpPr/>
+          <p:nvPr/>
+        </p:nvSpPr>
+        <p:spPr>
+          <a:xfrm>
+            <a:off x="8613648" y="2743200"/>
+            <a:ext cx="365760" cy="457200"/>
+          </a:xfrm>
+          <a:prstGeom prst="rect">
+            <a:avLst/>
+          </a:prstGeom>
+          <a:noFill/>
+          <a:ln/>
+        </p:spPr>
+        <p:txBody>
+          <a:bodyPr wrap="square" lIns="0" tIns="0" rIns="0" bIns="0" rtlCol="0" anchor="ctr"/>
+          <a:lstStyle/>
+          <a:p>
+            <a:pPr algn="ctr" indent="0" marL="0">
+              <a:buNone/>
+            </a:pPr>
+            <a:r>
+              <a:rPr lang="en-US" sz="2000" b="1" dirty="0">
+                <a:solidFill>
+                  <a:srgbClr val="5E7078"/>
+                </a:solidFill>
+                <a:latin typeface="Malgun Gothic" pitchFamily="34" charset="0"/>
+                <a:ea typeface="Malgun Gothic" pitchFamily="34" charset="-122"/>
+                <a:cs typeface="Malgun Gothic" pitchFamily="34" charset="-120"/>
+              </a:rPr>
+              <a:t>→</a:t>
+            </a:r>
+            <a:endParaRPr lang="en-US" sz="2000" dirty="0"/>
+          </a:p>
+        </p:txBody>
+      </p:sp>
+      <p:sp>
+        <p:nvSpPr>
+          <p:cNvPr id="21" name="Shape 16"/>
+          <p:cNvSpPr/>
+          <p:nvPr/>
+        </p:nvSpPr>
+        <p:spPr>
+          <a:xfrm>
+            <a:off x="8915400" y="1554480"/>
+            <a:ext cx="2468880" cy="2834640"/>
+          </a:xfrm>
+          <a:prstGeom prst="roundRect">
+            <a:avLst>
+              <a:gd name="adj" fmla="val 5185"/>
+            </a:avLst>
+          </a:prstGeom>
+          <a:solidFill>
+            <a:srgbClr val="E3F4F2"/>
+          </a:solidFill>
+          <a:ln/>
+        </p:spPr>
+      </p:sp>
+      <p:sp>
+        <p:nvSpPr>
+          <p:cNvPr id="22" name="Shape 17"/>
+          <p:cNvSpPr/>
+          <p:nvPr/>
+        </p:nvSpPr>
+        <p:spPr>
+          <a:xfrm>
+            <a:off x="9784080" y="1783080"/>
+            <a:ext cx="731520" cy="731520"/>
+          </a:xfrm>
+          <a:prstGeom prst="ellipse">
+            <a:avLst/>
+          </a:prstGeom>
+          <a:solidFill>
+            <a:srgbClr val="FFFFFF"/>
+          </a:solidFill>
+          <a:ln/>
+        </p:spPr>
+      </p:sp>
+      <p:pic>
+        <p:nvPicPr>
+          <p:cNvPr id="23" name="Image 3" descr="preencoded.png">    </p:cNvPr>
+          <p:cNvPicPr>
+            <a:picLocks noChangeAspect="1"/>
+          </p:cNvPicPr>
+          <p:nvPr/>
+        </p:nvPicPr>
+        <p:blipFill>
+          <a:blip r:embed="rId4"/>
+          <a:stretch>
+            <a:fillRect/>
+          </a:stretch>
+        </p:blipFill>
+        <p:spPr>
+          <a:xfrm>
+            <a:off x="9959645" y="1958645"/>
+            <a:ext cx="380390" cy="380390"/>
+          </a:xfrm>
+          <a:prstGeom prst="rect">
+            <a:avLst/>
+          </a:prstGeom>
+        </p:spPr>
+      </p:pic>
+      <p:sp>
+        <p:nvSpPr>
+          <p:cNvPr id="24" name="Text 18"/>
+          <p:cNvSpPr/>
+          <p:nvPr/>
+        </p:nvSpPr>
+        <p:spPr>
+          <a:xfrm>
+            <a:off x="9098280" y="2697480"/>
+            <a:ext cx="2103120" cy="411480"/>
+          </a:xfrm>
+          <a:prstGeom prst="rect">
+            <a:avLst/>
+          </a:prstGeom>
+          <a:noFill/>
+          <a:ln/>
+        </p:spPr>
+        <p:txBody>
+          <a:bodyPr wrap="square" lIns="0" tIns="0" rIns="0" bIns="0" rtlCol="0" anchor="ctr"/>
+          <a:lstStyle/>
+          <a:p>
+            <a:pPr algn="ctr" indent="0" marL="0">
+              <a:buNone/>
+            </a:pPr>
+            <a:r>
+              <a:rPr lang="en-US" sz="1550" b="1" dirty="0">
+                <a:solidFill>
+                  <a:srgbClr val="065A6E"/>
+                </a:solidFill>
+                <a:latin typeface="Malgun Gothic" pitchFamily="34" charset="0"/>
+                <a:ea typeface="Malgun Gothic" pitchFamily="34" charset="-122"/>
+                <a:cs typeface="Malgun Gothic" pitchFamily="34" charset="-120"/>
+              </a:rPr>
+              <a:t>4. 의견 쓰고 제출</a:t>
+            </a:r>
+            <a:endParaRPr lang="en-US" sz="1550" dirty="0"/>
+          </a:p>
+        </p:txBody>
+      </p:sp>
+      <p:sp>
+        <p:nvSpPr>
+          <p:cNvPr id="25" name="Text 19"/>
+          <p:cNvSpPr/>
+          <p:nvPr/>
+        </p:nvSpPr>
+        <p:spPr>
+          <a:xfrm>
+            <a:off x="9134856" y="3154680"/>
+            <a:ext cx="2029968" cy="1097280"/>
+          </a:xfrm>
+          <a:prstGeom prst="rect">
+            <a:avLst/>
+          </a:prstGeom>
+          <a:noFill/>
+          <a:ln/>
+        </p:spPr>
+        <p:txBody>
+          <a:bodyPr wrap="square" lIns="0" tIns="0" rIns="0" bIns="0" rtlCol="0" anchor="ctr"/>
+          <a:lstStyle/>
+          <a:p>
+            <a:pPr algn="ctr" indent="0" marL="0">
+              <a:lnSpc>
+                <a:spcPct val="115000"/>
+              </a:lnSpc>
+              <a:buNone/>
+            </a:pPr>
+            <a:r>
+              <a:rPr lang="en-US" sz="1200" dirty="0">
+                <a:solidFill>
+                  <a:srgbClr val="26343B"/>
+                </a:solidFill>
+                <a:latin typeface="Malgun Gothic" pitchFamily="34" charset="0"/>
+                <a:ea typeface="Malgun Gothic" pitchFamily="34" charset="-122"/>
+                <a:cs typeface="Malgun Gothic" pitchFamily="34" charset="-120"/>
+              </a:rPr>
+              <a:t>완성한 의견 글을 붙여 넣고 제출 버튼을 눌러요.</a:t>
+            </a:r>
+            <a:endParaRPr lang="en-US" sz="1200" dirty="0"/>
+          </a:p>
+        </p:txBody>
+      </p:sp>
+      <p:sp>
+        <p:nvSpPr>
+          <p:cNvPr id="26" name="Shape 20"/>
+          <p:cNvSpPr/>
+          <p:nvPr/>
+        </p:nvSpPr>
+        <p:spPr>
+          <a:xfrm>
+            <a:off x="822960" y="4754880"/>
+            <a:ext cx="10515600" cy="1371600"/>
+          </a:xfrm>
+          <a:prstGeom prst="roundRect">
+            <a:avLst>
+              <a:gd name="adj" fmla="val 8000"/>
+            </a:avLst>
+          </a:prstGeom>
+          <a:solidFill>
+            <a:srgbClr val="FFF6DE"/>
+          </a:solidFill>
+          <a:ln/>
+        </p:spPr>
+      </p:sp>
+      <p:sp>
+        <p:nvSpPr>
+          <p:cNvPr id="27" name="Shape 21"/>
+          <p:cNvSpPr/>
+          <p:nvPr/>
+        </p:nvSpPr>
+        <p:spPr>
+          <a:xfrm>
+            <a:off x="1051560" y="5029200"/>
+            <a:ext cx="566928" cy="566928"/>
+          </a:xfrm>
+          <a:prstGeom prst="ellipse">
+            <a:avLst/>
+          </a:prstGeom>
+          <a:solidFill>
+            <a:srgbClr val="FFFFFF"/>
+          </a:solidFill>
+          <a:ln/>
+        </p:spPr>
+      </p:sp>
+      <p:pic>
+        <p:nvPicPr>
+          <p:cNvPr id="28" name="Image 4" descr="preencoded.png">    </p:cNvPr>
+          <p:cNvPicPr>
+            <a:picLocks noChangeAspect="1"/>
+          </p:cNvPicPr>
+          <p:nvPr/>
+        </p:nvPicPr>
+        <p:blipFill>
+          <a:blip r:embed="rId5"/>
+          <a:stretch>
+            <a:fillRect/>
+          </a:stretch>
+        </p:blipFill>
+        <p:spPr>
+          <a:xfrm>
+            <a:off x="1198961" y="5176601"/>
+            <a:ext cx="272125" cy="272125"/>
+          </a:xfrm>
+          <a:prstGeom prst="rect">
+            <a:avLst/>
+          </a:prstGeom>
+        </p:spPr>
+      </p:pic>
+      <p:sp>
+        <p:nvSpPr>
+          <p:cNvPr id="29" name="Text 22"/>
+          <p:cNvSpPr/>
+          <p:nvPr/>
+        </p:nvSpPr>
+        <p:spPr>
+          <a:xfrm>
+            <a:off x="1828800" y="4956048"/>
+            <a:ext cx="9326880" cy="411480"/>
+          </a:xfrm>
+          <a:prstGeom prst="rect">
+            <a:avLst/>
+          </a:prstGeom>
+          <a:noFill/>
+          <a:ln/>
+        </p:spPr>
+        <p:txBody>
+          <a:bodyPr wrap="square" lIns="0" tIns="0" rIns="0" bIns="0" rtlCol="0" anchor="ctr"/>
+          <a:lstStyle/>
+          <a:p>
+            <a:pPr indent="0" marL="0">
+              <a:buNone/>
+            </a:pPr>
+            <a:r>
+              <a:rPr lang="en-US" sz="1550" b="1" dirty="0">
+                <a:solidFill>
+                  <a:srgbClr val="8A6100"/>
+                </a:solidFill>
+                <a:latin typeface="Malgun Gothic" pitchFamily="34" charset="0"/>
+                <a:ea typeface="Malgun Gothic" pitchFamily="34" charset="-122"/>
+                <a:cs typeface="Malgun Gothic" pitchFamily="34" charset="-120"/>
+              </a:rPr>
+              <a:t>제출 전에 꼭 확인!</a:t>
+            </a:r>
+            <a:endParaRPr lang="en-US" sz="1550" dirty="0"/>
+          </a:p>
+        </p:txBody>
+      </p:sp>
+      <p:sp>
+        <p:nvSpPr>
+          <p:cNvPr id="30" name="Text 23"/>
+          <p:cNvSpPr/>
+          <p:nvPr/>
+        </p:nvSpPr>
+        <p:spPr>
+          <a:xfrm>
+            <a:off x="1828800" y="5394960"/>
+            <a:ext cx="9326880" cy="548640"/>
+          </a:xfrm>
+          <a:prstGeom prst="rect">
+            <a:avLst/>
+          </a:prstGeom>
+          <a:noFill/>
+          <a:ln/>
+        </p:spPr>
+        <p:txBody>
+          <a:bodyPr wrap="square" lIns="0" tIns="0" rIns="0" bIns="0" rtlCol="0" anchor="ctr"/>
+          <a:lstStyle/>
+          <a:p>
+            <a:pPr indent="0" marL="0">
+              <a:buNone/>
+            </a:pPr>
+            <a:r>
+              <a:rPr lang="en-US" sz="1350" dirty="0">
+                <a:solidFill>
+                  <a:srgbClr val="26343B"/>
+                </a:solidFill>
+                <a:latin typeface="Malgun Gothic" pitchFamily="34" charset="0"/>
+                <a:ea typeface="Malgun Gothic" pitchFamily="34" charset="-122"/>
+                <a:cs typeface="Malgun Gothic" pitchFamily="34" charset="-120"/>
+              </a:rPr>
+              <a:t>① 자기점검 다섯 가지를 통과했나요?   ② 내 번호와 기사를 바르게 골랐나요?  (잘못 고르면 제출해도 ‘미제출’로 보여요)</a:t>
+            </a:r>
+            <a:endParaRPr lang="en-US" sz="1350" dirty="0"/>
+          </a:p>
+        </p:txBody>
+      </p:sp>
+    </p:spTree>
+  </p:cSld>
+  <p:clrMapOvr>
+    <a:masterClrMapping/>
+  </p:clrMapOvr>
+</p:sld>
+</file>
+
+<file path=ppt/slides/slide17.xml><?xml version="1.0" encoding="utf-8"?>
+<p:sld xmlns:a="http://schemas.openxmlformats.org/drawingml/2006/main" xmlns:r="http://schemas.openxmlformats.org/officeDocument/2006/relationships" xmlns:p="http://schemas.openxmlformats.org/presentationml/2006/main">
+  <p:cSld name="Slide 17">
     <p:bg>
       <p:bgPr>
         <a:solidFill>
@@ -8092,16 +9230,40 @@
           <a:ln/>
         </p:spPr>
       </p:sp>
-      <p:sp>
-        <p:nvSpPr>
-          <p:cNvPr id="20" name="Text 15"/>
-          <p:cNvSpPr/>
-          <p:nvPr/>
-        </p:nvSpPr>
-        <p:spPr>
-          <a:xfrm>
-            <a:off x="1097280" y="5193792"/>
-            <a:ext cx="9966960" cy="548640"/>
+      <p:pic>
+        <p:nvPicPr>
+          <p:cNvPr id="20" name="Image 3" descr="/root/.claude/skills/synced/edu-live-workshop/assets/gomgom-bear.png">    </p:cNvPr>
+          <p:cNvPicPr>
+            <a:picLocks noChangeAspect="1"/>
+          </p:cNvPicPr>
+          <p:nvPr/>
+        </p:nvPicPr>
+        <p:blipFill>
+          <a:blip r:embed="rId4"/>
+          <a:stretch>
+            <a:fillRect/>
+          </a:stretch>
+        </p:blipFill>
+        <p:spPr>
+          <a:xfrm>
+            <a:off x="1143000" y="4983480"/>
+            <a:ext cx="960120" cy="960120"/>
+          </a:xfrm>
+          <a:prstGeom prst="rect">
+            <a:avLst/>
+          </a:prstGeom>
+        </p:spPr>
+      </p:pic>
+      <p:sp>
+        <p:nvSpPr>
+          <p:cNvPr id="21" name="Text 15"/>
+          <p:cNvSpPr/>
+          <p:nvPr/>
+        </p:nvSpPr>
+        <p:spPr>
+          <a:xfrm>
+            <a:off x="2286000" y="5193792"/>
+            <a:ext cx="8778240" cy="548640"/>
           </a:xfrm>
           <a:prstGeom prst="rect">
             <a:avLst/>

</xml_diff>